<commit_message>
global.log introduced -- logs that land in dev-console of main window
</commit_message>
<xml_diff>
--- a/docs/Tech-overview.pptx
+++ b/docs/Tech-overview.pptx
@@ -262,7 +262,7 @@
           <a:p>
             <a:fld id="{CA855E1B-8830-B64E-B102-DB2BBD0D9567}" type="datetimeFigureOut">
               <a:rPr lang="sv-SE" smtClean="0"/>
-              <a:t>2024-12-03</a:t>
+              <a:t>2025-01-15</a:t>
             </a:fld>
             <a:endParaRPr lang="sv-SE"/>
           </a:p>
@@ -432,7 +432,7 @@
           <a:p>
             <a:fld id="{CA855E1B-8830-B64E-B102-DB2BBD0D9567}" type="datetimeFigureOut">
               <a:rPr lang="sv-SE" smtClean="0"/>
-              <a:t>2024-12-03</a:t>
+              <a:t>2025-01-15</a:t>
             </a:fld>
             <a:endParaRPr lang="sv-SE"/>
           </a:p>
@@ -612,7 +612,7 @@
           <a:p>
             <a:fld id="{CA855E1B-8830-B64E-B102-DB2BBD0D9567}" type="datetimeFigureOut">
               <a:rPr lang="sv-SE" smtClean="0"/>
-              <a:t>2024-12-03</a:t>
+              <a:t>2025-01-15</a:t>
             </a:fld>
             <a:endParaRPr lang="sv-SE"/>
           </a:p>
@@ -782,7 +782,7 @@
           <a:p>
             <a:fld id="{CA855E1B-8830-B64E-B102-DB2BBD0D9567}" type="datetimeFigureOut">
               <a:rPr lang="sv-SE" smtClean="0"/>
-              <a:t>2024-12-03</a:t>
+              <a:t>2025-01-15</a:t>
             </a:fld>
             <a:endParaRPr lang="sv-SE"/>
           </a:p>
@@ -1026,7 +1026,7 @@
           <a:p>
             <a:fld id="{CA855E1B-8830-B64E-B102-DB2BBD0D9567}" type="datetimeFigureOut">
               <a:rPr lang="sv-SE" smtClean="0"/>
-              <a:t>2024-12-03</a:t>
+              <a:t>2025-01-15</a:t>
             </a:fld>
             <a:endParaRPr lang="sv-SE"/>
           </a:p>
@@ -1258,7 +1258,7 @@
           <a:p>
             <a:fld id="{CA855E1B-8830-B64E-B102-DB2BBD0D9567}" type="datetimeFigureOut">
               <a:rPr lang="sv-SE" smtClean="0"/>
-              <a:t>2024-12-03</a:t>
+              <a:t>2025-01-15</a:t>
             </a:fld>
             <a:endParaRPr lang="sv-SE"/>
           </a:p>
@@ -1625,7 +1625,7 @@
           <a:p>
             <a:fld id="{CA855E1B-8830-B64E-B102-DB2BBD0D9567}" type="datetimeFigureOut">
               <a:rPr lang="sv-SE" smtClean="0"/>
-              <a:t>2024-12-03</a:t>
+              <a:t>2025-01-15</a:t>
             </a:fld>
             <a:endParaRPr lang="sv-SE"/>
           </a:p>
@@ -1743,7 +1743,7 @@
           <a:p>
             <a:fld id="{CA855E1B-8830-B64E-B102-DB2BBD0D9567}" type="datetimeFigureOut">
               <a:rPr lang="sv-SE" smtClean="0"/>
-              <a:t>2024-12-03</a:t>
+              <a:t>2025-01-15</a:t>
             </a:fld>
             <a:endParaRPr lang="sv-SE"/>
           </a:p>
@@ -1838,7 +1838,7 @@
           <a:p>
             <a:fld id="{CA855E1B-8830-B64E-B102-DB2BBD0D9567}" type="datetimeFigureOut">
               <a:rPr lang="sv-SE" smtClean="0"/>
-              <a:t>2024-12-03</a:t>
+              <a:t>2025-01-15</a:t>
             </a:fld>
             <a:endParaRPr lang="sv-SE"/>
           </a:p>
@@ -2115,7 +2115,7 @@
           <a:p>
             <a:fld id="{CA855E1B-8830-B64E-B102-DB2BBD0D9567}" type="datetimeFigureOut">
               <a:rPr lang="sv-SE" smtClean="0"/>
-              <a:t>2024-12-03</a:t>
+              <a:t>2025-01-15</a:t>
             </a:fld>
             <a:endParaRPr lang="sv-SE"/>
           </a:p>
@@ -2372,7 +2372,7 @@
           <a:p>
             <a:fld id="{CA855E1B-8830-B64E-B102-DB2BBD0D9567}" type="datetimeFigureOut">
               <a:rPr lang="sv-SE" smtClean="0"/>
-              <a:t>2024-12-03</a:t>
+              <a:t>2025-01-15</a:t>
             </a:fld>
             <a:endParaRPr lang="sv-SE"/>
           </a:p>
@@ -2585,7 +2585,7 @@
           <a:p>
             <a:fld id="{CA855E1B-8830-B64E-B102-DB2BBD0D9567}" type="datetimeFigureOut">
               <a:rPr lang="sv-SE" smtClean="0"/>
-              <a:t>2024-12-03</a:t>
+              <a:t>2025-01-15</a:t>
             </a:fld>
             <a:endParaRPr lang="sv-SE"/>
           </a:p>
@@ -14082,7 +14082,7 @@
         <p:spPr>
           <a:xfrm>
             <a:off x="401904" y="1545040"/>
-            <a:ext cx="3274288" cy="3539430"/>
+            <a:ext cx="3274288" cy="4154984"/>
           </a:xfrm>
           <a:prstGeom prst="rect">
             <a:avLst/>
@@ -14326,6 +14326,43 @@
               <a:rPr lang="en-US" sz="800" noProof="1"/>
               <a:t>(or similar command, use function starting on load)</a:t>
             </a:r>
+          </a:p>
+          <a:p>
+            <a:pPr marL="171450" indent="-171450">
+              <a:buFont typeface="Courier New" panose="02070309020205020404" pitchFamily="49" charset="0"/>
+              <a:buChar char="o"/>
+            </a:pPr>
+            <a:endParaRPr lang="en-US" sz="800" noProof="1"/>
+          </a:p>
+          <a:p>
+            <a:r>
+              <a:rPr lang="en-US" sz="800" b="1" noProof="1"/>
+              <a:t>Console.log to main dev console</a:t>
+            </a:r>
+          </a:p>
+          <a:p>
+            <a:pPr marL="171450" indent="-171450">
+              <a:buFont typeface="Courier New" panose="02070309020205020404" pitchFamily="49" charset="0"/>
+              <a:buChar char="o"/>
+            </a:pPr>
+            <a:r>
+              <a:rPr lang="en-US" sz="800" noProof="1"/>
+              <a:t>Define global.log function in app.js, which logs from everywhere to main dev console</a:t>
+            </a:r>
+          </a:p>
+          <a:p>
+            <a:pPr marL="171450" indent="-171450">
+              <a:buFont typeface="Courier New" panose="02070309020205020404" pitchFamily="49" charset="0"/>
+              <a:buChar char="o"/>
+            </a:pPr>
+            <a:r>
+              <a:rPr lang="en-US" sz="800" noProof="1">
+                <a:latin typeface="Courier New" panose="02070309020205020404" pitchFamily="49" charset="0"/>
+                <a:cs typeface="Courier New" panose="02070309020205020404" pitchFamily="49" charset="0"/>
+              </a:rPr>
+              <a:t>global.log(‘message’)</a:t>
+            </a:r>
+            <a:endParaRPr lang="en-US" sz="800" noProof="1"/>
           </a:p>
           <a:p>
             <a:br>

</xml_diff>

<commit_message>
ssh folder -- prototype running pragma-merge on remote ssh folder
TEST AS IS:

Client : ChangedFileList, click diff

Client terminal:  cd  ~/Documents/Projects/Pragma-git/pragma-git;  ./ssh-pragma-merge-files ssh://jan@home-jan-ubuntu/home/jan/Desktop/ssh_local_test

Remote terminal (after closing window): cd ~/.Pragma-git/.tmp;  rm pragma-merge-running-ssh

.git/config add
[mergetool "pragma-git"]
cmd = /home/jan/Desktop/Pragma-git-dev/pragma-merge $BASE $LOCAL $REMOTE $MERGED 'ssh'
</commit_message>
<xml_diff>
--- a/docs/Tech-overview.pptx
+++ b/docs/Tech-overview.pptx
@@ -263,7 +263,7 @@
           <a:p>
             <a:fld id="{CA855E1B-8830-B64E-B102-DB2BBD0D9567}" type="datetimeFigureOut">
               <a:rPr lang="sv-SE" smtClean="0"/>
-              <a:t>2025-04-27</a:t>
+              <a:t>2025-05-20</a:t>
             </a:fld>
             <a:endParaRPr lang="sv-SE"/>
           </a:p>
@@ -433,7 +433,7 @@
           <a:p>
             <a:fld id="{CA855E1B-8830-B64E-B102-DB2BBD0D9567}" type="datetimeFigureOut">
               <a:rPr lang="sv-SE" smtClean="0"/>
-              <a:t>2025-04-27</a:t>
+              <a:t>2025-05-20</a:t>
             </a:fld>
             <a:endParaRPr lang="sv-SE"/>
           </a:p>
@@ -613,7 +613,7 @@
           <a:p>
             <a:fld id="{CA855E1B-8830-B64E-B102-DB2BBD0D9567}" type="datetimeFigureOut">
               <a:rPr lang="sv-SE" smtClean="0"/>
-              <a:t>2025-04-27</a:t>
+              <a:t>2025-05-20</a:t>
             </a:fld>
             <a:endParaRPr lang="sv-SE"/>
           </a:p>
@@ -783,7 +783,7 @@
           <a:p>
             <a:fld id="{CA855E1B-8830-B64E-B102-DB2BBD0D9567}" type="datetimeFigureOut">
               <a:rPr lang="sv-SE" smtClean="0"/>
-              <a:t>2025-04-27</a:t>
+              <a:t>2025-05-20</a:t>
             </a:fld>
             <a:endParaRPr lang="sv-SE"/>
           </a:p>
@@ -1027,7 +1027,7 @@
           <a:p>
             <a:fld id="{CA855E1B-8830-B64E-B102-DB2BBD0D9567}" type="datetimeFigureOut">
               <a:rPr lang="sv-SE" smtClean="0"/>
-              <a:t>2025-04-27</a:t>
+              <a:t>2025-05-20</a:t>
             </a:fld>
             <a:endParaRPr lang="sv-SE"/>
           </a:p>
@@ -1259,7 +1259,7 @@
           <a:p>
             <a:fld id="{CA855E1B-8830-B64E-B102-DB2BBD0D9567}" type="datetimeFigureOut">
               <a:rPr lang="sv-SE" smtClean="0"/>
-              <a:t>2025-04-27</a:t>
+              <a:t>2025-05-20</a:t>
             </a:fld>
             <a:endParaRPr lang="sv-SE"/>
           </a:p>
@@ -1626,7 +1626,7 @@
           <a:p>
             <a:fld id="{CA855E1B-8830-B64E-B102-DB2BBD0D9567}" type="datetimeFigureOut">
               <a:rPr lang="sv-SE" smtClean="0"/>
-              <a:t>2025-04-27</a:t>
+              <a:t>2025-05-20</a:t>
             </a:fld>
             <a:endParaRPr lang="sv-SE"/>
           </a:p>
@@ -1744,7 +1744,7 @@
           <a:p>
             <a:fld id="{CA855E1B-8830-B64E-B102-DB2BBD0D9567}" type="datetimeFigureOut">
               <a:rPr lang="sv-SE" smtClean="0"/>
-              <a:t>2025-04-27</a:t>
+              <a:t>2025-05-20</a:t>
             </a:fld>
             <a:endParaRPr lang="sv-SE"/>
           </a:p>
@@ -1839,7 +1839,7 @@
           <a:p>
             <a:fld id="{CA855E1B-8830-B64E-B102-DB2BBD0D9567}" type="datetimeFigureOut">
               <a:rPr lang="sv-SE" smtClean="0"/>
-              <a:t>2025-04-27</a:t>
+              <a:t>2025-05-20</a:t>
             </a:fld>
             <a:endParaRPr lang="sv-SE"/>
           </a:p>
@@ -2116,7 +2116,7 @@
           <a:p>
             <a:fld id="{CA855E1B-8830-B64E-B102-DB2BBD0D9567}" type="datetimeFigureOut">
               <a:rPr lang="sv-SE" smtClean="0"/>
-              <a:t>2025-04-27</a:t>
+              <a:t>2025-05-20</a:t>
             </a:fld>
             <a:endParaRPr lang="sv-SE"/>
           </a:p>
@@ -2373,7 +2373,7 @@
           <a:p>
             <a:fld id="{CA855E1B-8830-B64E-B102-DB2BBD0D9567}" type="datetimeFigureOut">
               <a:rPr lang="sv-SE" smtClean="0"/>
-              <a:t>2025-04-27</a:t>
+              <a:t>2025-05-20</a:t>
             </a:fld>
             <a:endParaRPr lang="sv-SE"/>
           </a:p>
@@ -2586,7 +2586,7 @@
           <a:p>
             <a:fld id="{CA855E1B-8830-B64E-B102-DB2BBD0D9567}" type="datetimeFigureOut">
               <a:rPr lang="sv-SE" smtClean="0"/>
-              <a:t>2025-04-27</a:t>
+              <a:t>2025-05-20</a:t>
             </a:fld>
             <a:endParaRPr lang="sv-SE"/>
           </a:p>
@@ -11129,7 +11129,7 @@
         <p:spPr>
           <a:xfrm>
             <a:off x="416902" y="1472403"/>
-            <a:ext cx="5396401" cy="5755422"/>
+            <a:ext cx="5396401" cy="5878532"/>
           </a:xfrm>
           <a:prstGeom prst="rect">
             <a:avLst/>
@@ -11182,6 +11182,16 @@
               <a:rPr lang="en-US" sz="800" b="1" noProof="1"/>
               <a:t>I had to make a bash script which places signal files, that are then picked up by pragma-git</a:t>
             </a:r>
+          </a:p>
+          <a:p>
+            <a:pPr marL="171450" indent="-171450">
+              <a:buFontTx/>
+              <a:buChar char="-"/>
+            </a:pPr>
+            <a:r>
+              <a:rPr lang="en-US" sz="800" b="1" noProof="1"/>
+              <a:t>The sigalling file “pragma-merge-running” is controlling the flow between git and pragma-merge (via pragma-git)</a:t>
+            </a:r>
             <a:br>
               <a:rPr lang="en-US" sz="800" b="1" noProof="1"/>
             </a:br>
@@ -11350,13 +11360,17 @@
               <a:buChar char="•"/>
             </a:pPr>
             <a:r>
-              <a:rPr lang="en-US" sz="800" noProof="1"/>
-              <a:t>pragma-merge-running # Flag to start pragma-merge.js. Polled by script ‘pragma-merge’ to know when finished</a:t>
+              <a:rPr lang="en-US" sz="800" b="1" noProof="1"/>
+              <a:t>pragma-merge-running</a:t>
+            </a:r>
+            <a:r>
+              <a:rPr lang="en-US" sz="800" noProof="1"/>
+              <a:t> # Flag to start pragma-merge.js. Polled by script ‘pragma-merge’ to know when finished</a:t>
             </a:r>
             <a:br>
-              <a:rPr lang="en-US" sz="800" noProof="1"/>
+              <a:rPr lang="en-US" sz="800" b="1" noProof="1"/>
             </a:br>
-            <a:endParaRPr lang="en-US" sz="800" noProof="1"/>
+            <a:endParaRPr lang="en-US" sz="800" b="1" noProof="1"/>
           </a:p>
           <a:p>
             <a:pPr marL="171450" indent="-171450">
@@ -11457,9 +11471,17 @@
                   <a:schemeClr val="accent1"/>
                 </a:solidFill>
               </a:rPr>
-              <a:t>Pragma-git listens to creation of file ‘pragma-merge-running’</a:t>
-            </a:r>
-            <a:endParaRPr lang="en-US" sz="800" noProof="1"/>
+              <a:t>Pragma-git listens to creation of file </a:t>
+            </a:r>
+            <a:r>
+              <a:rPr lang="en-US" sz="800" b="1" noProof="1">
+                <a:solidFill>
+                  <a:schemeClr val="accent1"/>
+                </a:solidFill>
+              </a:rPr>
+              <a:t>‘pragma-merge-running’</a:t>
+            </a:r>
+            <a:endParaRPr lang="en-US" sz="800" b="1" noProof="1"/>
           </a:p>
           <a:p>
             <a:pPr marL="324000" lvl="1" indent="-171450">
@@ -11498,7 +11520,15 @@
             </a:pPr>
             <a:r>
               <a:rPr lang="en-US" sz="800" noProof="1"/>
-              <a:t>file ’pragma-merge-running’ is deleted to signal that ‘pragma-merge.js’ is closed</a:t>
+              <a:t>file </a:t>
+            </a:r>
+            <a:r>
+              <a:rPr lang="en-US" sz="800" b="1" noProof="1"/>
+              <a:t>’pragma-merge-running</a:t>
+            </a:r>
+            <a:r>
+              <a:rPr lang="en-US" sz="800" noProof="1"/>
+              <a:t>’ is deleted to signal that ‘pragma-merge.js’ is closed</a:t>
             </a:r>
           </a:p>
           <a:p>
@@ -11540,7 +11570,11 @@
             </a:pPr>
             <a:r>
               <a:rPr lang="en-US" sz="800" noProof="1"/>
-              <a:t>waits for deletion of file ‘pragma-merge-running’</a:t>
+              <a:t>waits for deletion of file </a:t>
+            </a:r>
+            <a:r>
+              <a:rPr lang="en-US" sz="800" b="1" noProof="1"/>
+              <a:t>‘pragma-merge-running’</a:t>
             </a:r>
           </a:p>
           <a:p>
@@ -11587,7 +11621,7 @@
         </p:nvSpPr>
         <p:spPr>
           <a:xfrm>
-            <a:off x="416901" y="7263108"/>
+            <a:off x="416902" y="7408417"/>
             <a:ext cx="5396401" cy="584775"/>
           </a:xfrm>
           <a:prstGeom prst="rect">

</xml_diff>

<commit_message>
Document ssh-git-client & Pragma-merge over ssh
</commit_message>
<xml_diff>
--- a/docs/Tech-overview.pptx
+++ b/docs/Tech-overview.pptx
@@ -13925,6 +13925,113 @@
       </p:grpSpPr>
       <p:sp>
         <p:nvSpPr>
+          <p:cNvPr id="122" name="Rectangle 121">
+            <a:extLst>
+              <a:ext uri="{FF2B5EF4-FFF2-40B4-BE49-F238E27FC236}">
+                <a16:creationId xmlns:a16="http://schemas.microsoft.com/office/drawing/2014/main" id="{4E4F468A-0631-842A-FCA7-FC0E33825BE9}"/>
+              </a:ext>
+            </a:extLst>
+          </p:cNvPr>
+          <p:cNvSpPr/>
+          <p:nvPr/>
+        </p:nvSpPr>
+        <p:spPr>
+          <a:xfrm>
+            <a:off x="451706" y="3328078"/>
+            <a:ext cx="11226129" cy="5950956"/>
+          </a:xfrm>
+          <a:prstGeom prst="rect">
+            <a:avLst/>
+          </a:prstGeom>
+          <a:solidFill>
+            <a:schemeClr val="bg2">
+              <a:lumMod val="90000"/>
+              <a:alpha val="33000"/>
+            </a:schemeClr>
+          </a:solidFill>
+          <a:ln w="0"/>
+        </p:spPr>
+        <p:style>
+          <a:lnRef idx="2">
+            <a:schemeClr val="accent1">
+              <a:shade val="15000"/>
+            </a:schemeClr>
+          </a:lnRef>
+          <a:fillRef idx="1">
+            <a:schemeClr val="accent1"/>
+          </a:fillRef>
+          <a:effectRef idx="0">
+            <a:schemeClr val="accent1"/>
+          </a:effectRef>
+          <a:fontRef idx="minor">
+            <a:schemeClr val="lt1"/>
+          </a:fontRef>
+        </p:style>
+        <p:txBody>
+          <a:bodyPr rtlCol="0" anchor="ctr"/>
+          <a:lstStyle/>
+          <a:p>
+            <a:pPr algn="ctr"/>
+            <a:endParaRPr lang="en-US" dirty="0">
+              <a:highlight>
+                <a:srgbClr val="C0C0C0"/>
+              </a:highlight>
+            </a:endParaRPr>
+          </a:p>
+        </p:txBody>
+      </p:sp>
+      <p:sp>
+        <p:nvSpPr>
+          <p:cNvPr id="114" name="Rectangle 113">
+            <a:extLst>
+              <a:ext uri="{FF2B5EF4-FFF2-40B4-BE49-F238E27FC236}">
+                <a16:creationId xmlns:a16="http://schemas.microsoft.com/office/drawing/2014/main" id="{2A41965A-DA7A-7196-60F2-57BE4824CBCE}"/>
+              </a:ext>
+            </a:extLst>
+          </p:cNvPr>
+          <p:cNvSpPr/>
+          <p:nvPr/>
+        </p:nvSpPr>
+        <p:spPr>
+          <a:xfrm>
+            <a:off x="6096044" y="3562275"/>
+            <a:ext cx="5154004" cy="4462272"/>
+          </a:xfrm>
+          <a:prstGeom prst="rect">
+            <a:avLst/>
+          </a:prstGeom>
+          <a:solidFill>
+            <a:schemeClr val="bg1"/>
+          </a:solidFill>
+          <a:ln w="0"/>
+        </p:spPr>
+        <p:style>
+          <a:lnRef idx="2">
+            <a:schemeClr val="accent1">
+              <a:shade val="15000"/>
+            </a:schemeClr>
+          </a:lnRef>
+          <a:fillRef idx="1">
+            <a:schemeClr val="accent1"/>
+          </a:fillRef>
+          <a:effectRef idx="0">
+            <a:schemeClr val="accent1"/>
+          </a:effectRef>
+          <a:fontRef idx="minor">
+            <a:schemeClr val="lt1"/>
+          </a:fontRef>
+        </p:style>
+        <p:txBody>
+          <a:bodyPr rtlCol="0" anchor="ctr"/>
+          <a:lstStyle/>
+          <a:p>
+            <a:pPr algn="ctr"/>
+            <a:endParaRPr lang="en-US"/>
+          </a:p>
+        </p:txBody>
+      </p:sp>
+      <p:sp>
+        <p:nvSpPr>
           <p:cNvPr id="4" name="textruta 3">
             <a:extLst>
               <a:ext uri="{FF2B5EF4-FFF2-40B4-BE49-F238E27FC236}">
@@ -14129,13 +14236,15 @@
         </p:nvSpPr>
         <p:spPr>
           <a:xfrm>
-            <a:off x="498478" y="3422956"/>
-            <a:ext cx="3274288" cy="6124754"/>
+            <a:off x="599550" y="3562275"/>
+            <a:ext cx="5019594" cy="5509200"/>
           </a:xfrm>
           <a:prstGeom prst="rect">
             <a:avLst/>
           </a:prstGeom>
-          <a:noFill/>
+          <a:solidFill>
+            <a:schemeClr val="bg1"/>
+          </a:solidFill>
           <a:ln>
             <a:solidFill>
               <a:schemeClr val="accent1"/>
@@ -14563,8 +14672,8 @@
         </p:nvSpPr>
         <p:spPr>
           <a:xfrm>
-            <a:off x="336553" y="2878797"/>
-            <a:ext cx="2054537" cy="461665"/>
+            <a:off x="462390" y="2889686"/>
+            <a:ext cx="3176062" cy="461665"/>
           </a:xfrm>
           <a:prstGeom prst="rect">
             <a:avLst/>
@@ -14579,8 +14688,1545 @@
           <a:p>
             <a:r>
               <a:rPr lang="en-US" sz="2400" b="1" noProof="1"/>
+              <a:t>Pragma-merge over ssh</a:t>
+            </a:r>
+          </a:p>
+        </p:txBody>
+      </p:sp>
+      <p:cxnSp>
+        <p:nvCxnSpPr>
+          <p:cNvPr id="13" name="Straight Connector 12">
+            <a:extLst>
+              <a:ext uri="{FF2B5EF4-FFF2-40B4-BE49-F238E27FC236}">
+                <a16:creationId xmlns:a16="http://schemas.microsoft.com/office/drawing/2014/main" id="{AEDD6223-7018-132C-0215-5CEDAE45D71E}"/>
+              </a:ext>
+            </a:extLst>
+          </p:cNvPr>
+          <p:cNvCxnSpPr>
+            <a:cxnSpLocks/>
+          </p:cNvCxnSpPr>
+          <p:nvPr/>
+        </p:nvCxnSpPr>
+        <p:spPr>
+          <a:xfrm>
+            <a:off x="8662374" y="3777582"/>
+            <a:ext cx="0" cy="3660950"/>
+          </a:xfrm>
+          <a:prstGeom prst="line">
+            <a:avLst/>
+          </a:prstGeom>
+        </p:spPr>
+        <p:style>
+          <a:lnRef idx="1">
+            <a:schemeClr val="accent1"/>
+          </a:lnRef>
+          <a:fillRef idx="0">
+            <a:schemeClr val="accent1"/>
+          </a:fillRef>
+          <a:effectRef idx="0">
+            <a:schemeClr val="accent1"/>
+          </a:effectRef>
+          <a:fontRef idx="minor">
+            <a:schemeClr val="tx1"/>
+          </a:fontRef>
+        </p:style>
+      </p:cxnSp>
+      <p:cxnSp>
+        <p:nvCxnSpPr>
+          <p:cNvPr id="20" name="Straight Connector 19">
+            <a:extLst>
+              <a:ext uri="{FF2B5EF4-FFF2-40B4-BE49-F238E27FC236}">
+                <a16:creationId xmlns:a16="http://schemas.microsoft.com/office/drawing/2014/main" id="{20DDA672-5FBE-49E1-4339-C38C0F628F39}"/>
+              </a:ext>
+            </a:extLst>
+          </p:cNvPr>
+          <p:cNvCxnSpPr>
+            <a:cxnSpLocks/>
+          </p:cNvCxnSpPr>
+          <p:nvPr/>
+        </p:nvCxnSpPr>
+        <p:spPr>
+          <a:xfrm>
+            <a:off x="8607627" y="3793130"/>
+            <a:ext cx="0" cy="3660950"/>
+          </a:xfrm>
+          <a:prstGeom prst="line">
+            <a:avLst/>
+          </a:prstGeom>
+        </p:spPr>
+        <p:style>
+          <a:lnRef idx="1">
+            <a:schemeClr val="accent1"/>
+          </a:lnRef>
+          <a:fillRef idx="0">
+            <a:schemeClr val="accent1"/>
+          </a:fillRef>
+          <a:effectRef idx="0">
+            <a:schemeClr val="accent1"/>
+          </a:effectRef>
+          <a:fontRef idx="minor">
+            <a:schemeClr val="tx1"/>
+          </a:fontRef>
+        </p:style>
+      </p:cxnSp>
+      <p:sp>
+        <p:nvSpPr>
+          <p:cNvPr id="22" name="TextBox 21">
+            <a:extLst>
+              <a:ext uri="{FF2B5EF4-FFF2-40B4-BE49-F238E27FC236}">
+                <a16:creationId xmlns:a16="http://schemas.microsoft.com/office/drawing/2014/main" id="{B171B19D-1094-8E83-91A6-310B6F4C49B2}"/>
+              </a:ext>
+            </a:extLst>
+          </p:cNvPr>
+          <p:cNvSpPr txBox="1"/>
+          <p:nvPr/>
+        </p:nvSpPr>
+        <p:spPr>
+          <a:xfrm>
+            <a:off x="6729172" y="3670019"/>
+            <a:ext cx="572366" cy="246221"/>
+          </a:xfrm>
+          <a:prstGeom prst="rect">
+            <a:avLst/>
+          </a:prstGeom>
+          <a:noFill/>
+        </p:spPr>
+        <p:txBody>
+          <a:bodyPr wrap="square">
+            <a:spAutoFit/>
+          </a:bodyPr>
+          <a:lstStyle/>
+          <a:p>
+            <a:r>
+              <a:rPr lang="en-US" sz="1000" b="1" noProof="1"/>
+              <a:t>CLIENT</a:t>
+            </a:r>
+            <a:endParaRPr lang="en-US" sz="1000" b="1" dirty="0"/>
+          </a:p>
+        </p:txBody>
+      </p:sp>
+      <p:sp>
+        <p:nvSpPr>
+          <p:cNvPr id="23" name="TextBox 22">
+            <a:extLst>
+              <a:ext uri="{FF2B5EF4-FFF2-40B4-BE49-F238E27FC236}">
+                <a16:creationId xmlns:a16="http://schemas.microsoft.com/office/drawing/2014/main" id="{400136D7-C5AA-7877-0320-1A2EF067C287}"/>
+              </a:ext>
+            </a:extLst>
+          </p:cNvPr>
+          <p:cNvSpPr txBox="1"/>
+          <p:nvPr/>
+        </p:nvSpPr>
+        <p:spPr>
+          <a:xfrm>
+            <a:off x="9281254" y="3639459"/>
+            <a:ext cx="820793" cy="246221"/>
+          </a:xfrm>
+          <a:prstGeom prst="rect">
+            <a:avLst/>
+          </a:prstGeom>
+          <a:noFill/>
+        </p:spPr>
+        <p:txBody>
+          <a:bodyPr wrap="square">
+            <a:spAutoFit/>
+          </a:bodyPr>
+          <a:lstStyle/>
+          <a:p>
+            <a:r>
+              <a:rPr lang="en-US" sz="1000" b="1" noProof="1"/>
+              <a:t>SERVER</a:t>
+            </a:r>
+            <a:endParaRPr lang="en-US" sz="1000" b="1" dirty="0"/>
+          </a:p>
+        </p:txBody>
+      </p:sp>
+      <p:sp>
+        <p:nvSpPr>
+          <p:cNvPr id="26" name="TextBox 25">
+            <a:extLst>
+              <a:ext uri="{FF2B5EF4-FFF2-40B4-BE49-F238E27FC236}">
+                <a16:creationId xmlns:a16="http://schemas.microsoft.com/office/drawing/2014/main" id="{62660ABB-182B-9D0E-3E01-E1CD397DF493}"/>
+              </a:ext>
+            </a:extLst>
+          </p:cNvPr>
+          <p:cNvSpPr txBox="1"/>
+          <p:nvPr/>
+        </p:nvSpPr>
+        <p:spPr>
+          <a:xfrm>
+            <a:off x="6398112" y="4092381"/>
+            <a:ext cx="2017955" cy="400110"/>
+          </a:xfrm>
+          <a:prstGeom prst="rect">
+            <a:avLst/>
+          </a:prstGeom>
+          <a:noFill/>
+        </p:spPr>
+        <p:txBody>
+          <a:bodyPr wrap="square">
+            <a:spAutoFit/>
+          </a:bodyPr>
+          <a:lstStyle/>
+          <a:p>
+            <a:r>
+              <a:rPr lang="en-US" sz="1000" noProof="1">
+                <a:solidFill>
+                  <a:schemeClr val="accent1"/>
+                </a:solidFill>
+              </a:rPr>
+              <a:t>ssh-git-client ...</a:t>
+            </a:r>
+            <a:br>
+              <a:rPr lang="en-US" sz="1000" noProof="1">
+                <a:solidFill>
+                  <a:schemeClr val="accent1"/>
+                </a:solidFill>
+              </a:rPr>
+            </a:br>
+            <a:r>
+              <a:rPr lang="en-US" sz="1000" noProof="1">
+                <a:solidFill>
+                  <a:schemeClr val="accent1"/>
+                </a:solidFill>
+              </a:rPr>
+              <a:t>…difftool –tool pragma-merge ….</a:t>
+            </a:r>
+            <a:endParaRPr lang="en-US" sz="1000" dirty="0"/>
+          </a:p>
+        </p:txBody>
+      </p:sp>
+      <p:sp>
+        <p:nvSpPr>
+          <p:cNvPr id="27" name="TextBox 26">
+            <a:extLst>
+              <a:ext uri="{FF2B5EF4-FFF2-40B4-BE49-F238E27FC236}">
+                <a16:creationId xmlns:a16="http://schemas.microsoft.com/office/drawing/2014/main" id="{5F48E1E5-4708-8811-A2C3-E6832D47D186}"/>
+              </a:ext>
+            </a:extLst>
+          </p:cNvPr>
+          <p:cNvSpPr txBox="1"/>
+          <p:nvPr/>
+        </p:nvSpPr>
+        <p:spPr>
+          <a:xfrm>
+            <a:off x="6316175" y="6954099"/>
+            <a:ext cx="1933523" cy="400110"/>
+          </a:xfrm>
+          <a:prstGeom prst="rect">
+            <a:avLst/>
+          </a:prstGeom>
+          <a:noFill/>
+        </p:spPr>
+        <p:txBody>
+          <a:bodyPr wrap="square">
+            <a:spAutoFit/>
+          </a:bodyPr>
+          <a:lstStyle/>
+          <a:p>
+            <a:r>
+              <a:rPr lang="en-US" sz="1000" noProof="1">
+                <a:solidFill>
+                  <a:schemeClr val="accent1"/>
+                </a:solidFill>
+              </a:rPr>
+              <a:t>User closing pragma-merge , runs</a:t>
+            </a:r>
+          </a:p>
+          <a:p>
+            <a:r>
+              <a:rPr lang="en-US" sz="1000" noProof="1">
+                <a:solidFill>
+                  <a:schemeClr val="accent1"/>
+                </a:solidFill>
+              </a:rPr>
+              <a:t>ssh-close-pragma-merge-ssh</a:t>
+            </a:r>
+            <a:endParaRPr lang="en-US" sz="1000" dirty="0"/>
+          </a:p>
+        </p:txBody>
+      </p:sp>
+      <p:sp>
+        <p:nvSpPr>
+          <p:cNvPr id="28" name="TextBox 27">
+            <a:extLst>
+              <a:ext uri="{FF2B5EF4-FFF2-40B4-BE49-F238E27FC236}">
+                <a16:creationId xmlns:a16="http://schemas.microsoft.com/office/drawing/2014/main" id="{5813F1E9-ED83-A50E-4EC1-55B9E8B4303A}"/>
+              </a:ext>
+            </a:extLst>
+          </p:cNvPr>
+          <p:cNvSpPr txBox="1"/>
+          <p:nvPr/>
+        </p:nvSpPr>
+        <p:spPr>
+          <a:xfrm>
+            <a:off x="6450266" y="4610042"/>
+            <a:ext cx="1933528" cy="246221"/>
+          </a:xfrm>
+          <a:prstGeom prst="rect">
+            <a:avLst/>
+          </a:prstGeom>
+          <a:noFill/>
+        </p:spPr>
+        <p:txBody>
+          <a:bodyPr wrap="square">
+            <a:spAutoFit/>
+          </a:bodyPr>
+          <a:lstStyle/>
+          <a:p>
+            <a:r>
+              <a:rPr lang="en-US" sz="1000" noProof="1">
+                <a:solidFill>
+                  <a:schemeClr val="accent1"/>
+                </a:solidFill>
+              </a:rPr>
+              <a:t>delayed-start-pragma-merge</a:t>
+            </a:r>
+            <a:endParaRPr lang="en-US" sz="1000" dirty="0"/>
+          </a:p>
+        </p:txBody>
+      </p:sp>
+      <p:sp>
+        <p:nvSpPr>
+          <p:cNvPr id="29" name="TextBox 28">
+            <a:extLst>
+              <a:ext uri="{FF2B5EF4-FFF2-40B4-BE49-F238E27FC236}">
+                <a16:creationId xmlns:a16="http://schemas.microsoft.com/office/drawing/2014/main" id="{C461B8D8-3994-94CC-FC6D-C267418FEE83}"/>
+              </a:ext>
+            </a:extLst>
+          </p:cNvPr>
+          <p:cNvSpPr txBox="1"/>
+          <p:nvPr/>
+        </p:nvSpPr>
+        <p:spPr>
+          <a:xfrm>
+            <a:off x="6520892" y="5394482"/>
+            <a:ext cx="1527306" cy="246221"/>
+          </a:xfrm>
+          <a:prstGeom prst="rect">
+            <a:avLst/>
+          </a:prstGeom>
+          <a:noFill/>
+        </p:spPr>
+        <p:txBody>
+          <a:bodyPr wrap="square">
+            <a:spAutoFit/>
+          </a:bodyPr>
+          <a:lstStyle/>
+          <a:p>
+            <a:r>
+              <a:rPr lang="en-US" sz="1000" noProof="1">
+                <a:solidFill>
+                  <a:schemeClr val="accent1"/>
+                </a:solidFill>
+              </a:rPr>
+              <a:t>ssh-pragma-merge-files</a:t>
+            </a:r>
+            <a:endParaRPr lang="en-US" sz="1000" dirty="0"/>
+          </a:p>
+        </p:txBody>
+      </p:sp>
+      <p:sp>
+        <p:nvSpPr>
+          <p:cNvPr id="32" name="TextBox 31">
+            <a:extLst>
+              <a:ext uri="{FF2B5EF4-FFF2-40B4-BE49-F238E27FC236}">
+                <a16:creationId xmlns:a16="http://schemas.microsoft.com/office/drawing/2014/main" id="{A04ED13C-32DC-0FB1-B3B7-5BC6F4EE854C}"/>
+              </a:ext>
+            </a:extLst>
+          </p:cNvPr>
+          <p:cNvSpPr txBox="1"/>
+          <p:nvPr/>
+        </p:nvSpPr>
+        <p:spPr>
+          <a:xfrm>
+            <a:off x="8730617" y="4996254"/>
+            <a:ext cx="1007468" cy="246221"/>
+          </a:xfrm>
+          <a:prstGeom prst="rect">
+            <a:avLst/>
+          </a:prstGeom>
+          <a:noFill/>
+        </p:spPr>
+        <p:txBody>
+          <a:bodyPr wrap="square">
+            <a:spAutoFit/>
+          </a:bodyPr>
+          <a:lstStyle/>
+          <a:p>
+            <a:r>
+              <a:rPr lang="en-US" sz="1000" noProof="1">
+                <a:solidFill>
+                  <a:schemeClr val="accent1"/>
+                </a:solidFill>
+              </a:rPr>
               <a:t>Pragma-merge</a:t>
             </a:r>
+            <a:endParaRPr lang="en-US" sz="1000" dirty="0"/>
+          </a:p>
+        </p:txBody>
+      </p:sp>
+      <p:sp>
+        <p:nvSpPr>
+          <p:cNvPr id="37" name="TextBox 36">
+            <a:extLst>
+              <a:ext uri="{FF2B5EF4-FFF2-40B4-BE49-F238E27FC236}">
+                <a16:creationId xmlns:a16="http://schemas.microsoft.com/office/drawing/2014/main" id="{03EB1486-6DBD-0ACE-D455-C6B6EFA9C921}"/>
+              </a:ext>
+            </a:extLst>
+          </p:cNvPr>
+          <p:cNvSpPr txBox="1"/>
+          <p:nvPr/>
+        </p:nvSpPr>
+        <p:spPr>
+          <a:xfrm>
+            <a:off x="9063029" y="4478912"/>
+            <a:ext cx="1348913" cy="400110"/>
+          </a:xfrm>
+          <a:prstGeom prst="rect">
+            <a:avLst/>
+          </a:prstGeom>
+          <a:noFill/>
+        </p:spPr>
+        <p:txBody>
+          <a:bodyPr wrap="square">
+            <a:spAutoFit/>
+          </a:bodyPr>
+          <a:lstStyle/>
+          <a:p>
+            <a:r>
+              <a:rPr lang="en-US" sz="1000" noProof="1"/>
+              <a:t>$BASE, $LOCAL, $REMOTE, $MERGED</a:t>
+            </a:r>
+            <a:endParaRPr lang="en-US" sz="1000" dirty="0"/>
+          </a:p>
+        </p:txBody>
+      </p:sp>
+      <p:sp>
+        <p:nvSpPr>
+          <p:cNvPr id="41" name="TextBox 40">
+            <a:extLst>
+              <a:ext uri="{FF2B5EF4-FFF2-40B4-BE49-F238E27FC236}">
+                <a16:creationId xmlns:a16="http://schemas.microsoft.com/office/drawing/2014/main" id="{7B632211-FD9F-9528-0621-7867C8F1306F}"/>
+              </a:ext>
+            </a:extLst>
+          </p:cNvPr>
+          <p:cNvSpPr txBox="1"/>
+          <p:nvPr/>
+        </p:nvSpPr>
+        <p:spPr>
+          <a:xfrm>
+            <a:off x="6483101" y="6442409"/>
+            <a:ext cx="1007468" cy="246221"/>
+          </a:xfrm>
+          <a:prstGeom prst="rect">
+            <a:avLst/>
+          </a:prstGeom>
+          <a:noFill/>
+        </p:spPr>
+        <p:txBody>
+          <a:bodyPr wrap="square">
+            <a:spAutoFit/>
+          </a:bodyPr>
+          <a:lstStyle/>
+          <a:p>
+            <a:r>
+              <a:rPr lang="en-US" sz="1000" noProof="1">
+                <a:solidFill>
+                  <a:schemeClr val="accent1"/>
+                </a:solidFill>
+              </a:rPr>
+              <a:t>pragma-merge</a:t>
+            </a:r>
+            <a:endParaRPr lang="en-US" sz="1000" dirty="0"/>
+          </a:p>
+        </p:txBody>
+      </p:sp>
+      <p:cxnSp>
+        <p:nvCxnSpPr>
+          <p:cNvPr id="42" name="Straight Arrow Connector 41">
+            <a:extLst>
+              <a:ext uri="{FF2B5EF4-FFF2-40B4-BE49-F238E27FC236}">
+                <a16:creationId xmlns:a16="http://schemas.microsoft.com/office/drawing/2014/main" id="{FBE719B7-B585-1413-3EBC-825AA7D8846B}"/>
+              </a:ext>
+            </a:extLst>
+          </p:cNvPr>
+          <p:cNvCxnSpPr>
+            <a:cxnSpLocks/>
+          </p:cNvCxnSpPr>
+          <p:nvPr/>
+        </p:nvCxnSpPr>
+        <p:spPr>
+          <a:xfrm>
+            <a:off x="6818173" y="4946241"/>
+            <a:ext cx="0" cy="493894"/>
+          </a:xfrm>
+          <a:prstGeom prst="straightConnector1">
+            <a:avLst/>
+          </a:prstGeom>
+          <a:ln>
+            <a:tailEnd type="triangle"/>
+          </a:ln>
+        </p:spPr>
+        <p:style>
+          <a:lnRef idx="1">
+            <a:schemeClr val="accent1"/>
+          </a:lnRef>
+          <a:fillRef idx="0">
+            <a:schemeClr val="accent1"/>
+          </a:fillRef>
+          <a:effectRef idx="0">
+            <a:schemeClr val="accent1"/>
+          </a:effectRef>
+          <a:fontRef idx="minor">
+            <a:schemeClr val="tx1"/>
+          </a:fontRef>
+        </p:style>
+      </p:cxnSp>
+      <p:sp>
+        <p:nvSpPr>
+          <p:cNvPr id="46" name="TextBox 45">
+            <a:extLst>
+              <a:ext uri="{FF2B5EF4-FFF2-40B4-BE49-F238E27FC236}">
+                <a16:creationId xmlns:a16="http://schemas.microsoft.com/office/drawing/2014/main" id="{077A5128-E8B7-5834-2321-F1AF04ED1419}"/>
+              </a:ext>
+            </a:extLst>
+          </p:cNvPr>
+          <p:cNvSpPr txBox="1"/>
+          <p:nvPr/>
+        </p:nvSpPr>
+        <p:spPr>
+          <a:xfrm>
+            <a:off x="9139275" y="5193914"/>
+            <a:ext cx="2317325" cy="246221"/>
+          </a:xfrm>
+          <a:prstGeom prst="rect">
+            <a:avLst/>
+          </a:prstGeom>
+          <a:noFill/>
+        </p:spPr>
+        <p:txBody>
+          <a:bodyPr wrap="square">
+            <a:spAutoFit/>
+          </a:bodyPr>
+          <a:lstStyle/>
+          <a:p>
+            <a:r>
+              <a:rPr lang="en-US" sz="1000" noProof="1"/>
+              <a:t>$TMP/pragma-merge-running-ssh</a:t>
+            </a:r>
+            <a:endParaRPr lang="en-US" sz="1000" dirty="0"/>
+          </a:p>
+        </p:txBody>
+      </p:sp>
+      <p:sp>
+        <p:nvSpPr>
+          <p:cNvPr id="47" name="TextBox 46">
+            <a:extLst>
+              <a:ext uri="{FF2B5EF4-FFF2-40B4-BE49-F238E27FC236}">
+                <a16:creationId xmlns:a16="http://schemas.microsoft.com/office/drawing/2014/main" id="{5073D0FC-C31D-2BD7-5554-ACD7B5EE87D9}"/>
+              </a:ext>
+            </a:extLst>
+          </p:cNvPr>
+          <p:cNvSpPr txBox="1"/>
+          <p:nvPr/>
+        </p:nvSpPr>
+        <p:spPr>
+          <a:xfrm>
+            <a:off x="9139275" y="5408002"/>
+            <a:ext cx="2317325" cy="400110"/>
+          </a:xfrm>
+          <a:prstGeom prst="rect">
+            <a:avLst/>
+          </a:prstGeom>
+          <a:noFill/>
+        </p:spPr>
+        <p:txBody>
+          <a:bodyPr wrap="square">
+            <a:spAutoFit/>
+          </a:bodyPr>
+          <a:lstStyle/>
+          <a:p>
+            <a:r>
+              <a:rPr lang="en-US" sz="1000" noProof="1"/>
+              <a:t>$FILE_LIST_ON_SSH</a:t>
+            </a:r>
+          </a:p>
+          <a:p>
+            <a:r>
+              <a:rPr lang="en-US" sz="1000" noProof="1"/>
+              <a:t>(list of $BASE, …, $MERGED)</a:t>
+            </a:r>
+            <a:endParaRPr lang="en-US" sz="1000" dirty="0"/>
+          </a:p>
+        </p:txBody>
+      </p:sp>
+      <p:cxnSp>
+        <p:nvCxnSpPr>
+          <p:cNvPr id="52" name="Straight Arrow Connector 51">
+            <a:extLst>
+              <a:ext uri="{FF2B5EF4-FFF2-40B4-BE49-F238E27FC236}">
+                <a16:creationId xmlns:a16="http://schemas.microsoft.com/office/drawing/2014/main" id="{6A72B33F-8720-5478-7BE4-58A901E1E409}"/>
+              </a:ext>
+            </a:extLst>
+          </p:cNvPr>
+          <p:cNvCxnSpPr>
+            <a:cxnSpLocks/>
+          </p:cNvCxnSpPr>
+          <p:nvPr/>
+        </p:nvCxnSpPr>
+        <p:spPr>
+          <a:xfrm>
+            <a:off x="6729172" y="5673826"/>
+            <a:ext cx="0" cy="790035"/>
+          </a:xfrm>
+          <a:prstGeom prst="straightConnector1">
+            <a:avLst/>
+          </a:prstGeom>
+          <a:ln>
+            <a:tailEnd type="triangle"/>
+          </a:ln>
+        </p:spPr>
+        <p:style>
+          <a:lnRef idx="1">
+            <a:schemeClr val="accent1"/>
+          </a:lnRef>
+          <a:fillRef idx="0">
+            <a:schemeClr val="accent1"/>
+          </a:fillRef>
+          <a:effectRef idx="0">
+            <a:schemeClr val="accent1"/>
+          </a:effectRef>
+          <a:fontRef idx="minor">
+            <a:schemeClr val="tx1"/>
+          </a:fontRef>
+        </p:style>
+      </p:cxnSp>
+      <p:sp>
+        <p:nvSpPr>
+          <p:cNvPr id="55" name="TextBox 54">
+            <a:extLst>
+              <a:ext uri="{FF2B5EF4-FFF2-40B4-BE49-F238E27FC236}">
+                <a16:creationId xmlns:a16="http://schemas.microsoft.com/office/drawing/2014/main" id="{01C0E38B-FEC3-0661-0883-6B52B7D25C76}"/>
+              </a:ext>
+            </a:extLst>
+          </p:cNvPr>
+          <p:cNvSpPr txBox="1"/>
+          <p:nvPr/>
+        </p:nvSpPr>
+        <p:spPr>
+          <a:xfrm>
+            <a:off x="6742370" y="5613252"/>
+            <a:ext cx="2145471" cy="400110"/>
+          </a:xfrm>
+          <a:prstGeom prst="rect">
+            <a:avLst/>
+          </a:prstGeom>
+          <a:noFill/>
+        </p:spPr>
+        <p:txBody>
+          <a:bodyPr wrap="square">
+            <a:spAutoFit/>
+          </a:bodyPr>
+          <a:lstStyle/>
+          <a:p>
+            <a:r>
+              <a:rPr lang="en-US" sz="1000" noProof="1"/>
+              <a:t>Download $FILE_LIST_ON_SSH to</a:t>
+            </a:r>
+            <a:br>
+              <a:rPr lang="en-US" sz="1000" noProof="1"/>
+            </a:br>
+            <a:r>
+              <a:rPr lang="en-US" sz="1000" noProof="1"/>
+              <a:t>$TEMP_FILE_LOCATION</a:t>
+            </a:r>
+            <a:endParaRPr lang="en-US" sz="1000" dirty="0"/>
+          </a:p>
+        </p:txBody>
+      </p:sp>
+      <p:sp>
+        <p:nvSpPr>
+          <p:cNvPr id="59" name="TextBox 58">
+            <a:extLst>
+              <a:ext uri="{FF2B5EF4-FFF2-40B4-BE49-F238E27FC236}">
+                <a16:creationId xmlns:a16="http://schemas.microsoft.com/office/drawing/2014/main" id="{6BD01BB4-853E-EDB9-0FB1-56005E292D73}"/>
+              </a:ext>
+            </a:extLst>
+          </p:cNvPr>
+          <p:cNvSpPr txBox="1"/>
+          <p:nvPr/>
+        </p:nvSpPr>
+        <p:spPr>
+          <a:xfrm>
+            <a:off x="8752878" y="4083946"/>
+            <a:ext cx="2370855" cy="400110"/>
+          </a:xfrm>
+          <a:prstGeom prst="rect">
+            <a:avLst/>
+          </a:prstGeom>
+          <a:noFill/>
+        </p:spPr>
+        <p:txBody>
+          <a:bodyPr wrap="square">
+            <a:spAutoFit/>
+          </a:bodyPr>
+          <a:lstStyle/>
+          <a:p>
+            <a:r>
+              <a:rPr lang="en-US" sz="1000" noProof="1">
+                <a:solidFill>
+                  <a:schemeClr val="accent1"/>
+                </a:solidFill>
+              </a:rPr>
+              <a:t>git difftool –tool pragma-merge ….</a:t>
+            </a:r>
+            <a:br>
+              <a:rPr lang="en-US" sz="1000" noProof="1">
+                <a:solidFill>
+                  <a:schemeClr val="accent1"/>
+                </a:solidFill>
+              </a:rPr>
+            </a:br>
+            <a:r>
+              <a:rPr lang="en-US" sz="1000" noProof="1">
+                <a:solidFill>
+                  <a:schemeClr val="accent1"/>
+                </a:solidFill>
+              </a:rPr>
+              <a:t>              Generates temp-files:</a:t>
+            </a:r>
+            <a:endParaRPr lang="en-US" sz="1000" dirty="0"/>
+          </a:p>
+        </p:txBody>
+      </p:sp>
+      <p:cxnSp>
+        <p:nvCxnSpPr>
+          <p:cNvPr id="62" name="Straight Arrow Connector 61">
+            <a:extLst>
+              <a:ext uri="{FF2B5EF4-FFF2-40B4-BE49-F238E27FC236}">
+                <a16:creationId xmlns:a16="http://schemas.microsoft.com/office/drawing/2014/main" id="{923F2FBD-ED69-F293-9816-58ECA6943E7B}"/>
+              </a:ext>
+            </a:extLst>
+          </p:cNvPr>
+          <p:cNvCxnSpPr>
+            <a:cxnSpLocks/>
+          </p:cNvCxnSpPr>
+          <p:nvPr/>
+        </p:nvCxnSpPr>
+        <p:spPr>
+          <a:xfrm>
+            <a:off x="8972052" y="4318770"/>
+            <a:ext cx="0" cy="726962"/>
+          </a:xfrm>
+          <a:prstGeom prst="straightConnector1">
+            <a:avLst/>
+          </a:prstGeom>
+          <a:ln>
+            <a:tailEnd type="triangle"/>
+          </a:ln>
+        </p:spPr>
+        <p:style>
+          <a:lnRef idx="1">
+            <a:schemeClr val="accent1"/>
+          </a:lnRef>
+          <a:fillRef idx="0">
+            <a:schemeClr val="accent1"/>
+          </a:fillRef>
+          <a:effectRef idx="0">
+            <a:schemeClr val="accent1"/>
+          </a:effectRef>
+          <a:fontRef idx="minor">
+            <a:schemeClr val="tx1"/>
+          </a:fontRef>
+        </p:style>
+      </p:cxnSp>
+      <p:cxnSp>
+        <p:nvCxnSpPr>
+          <p:cNvPr id="66" name="Elbow Connector 65">
+            <a:extLst>
+              <a:ext uri="{FF2B5EF4-FFF2-40B4-BE49-F238E27FC236}">
+                <a16:creationId xmlns:a16="http://schemas.microsoft.com/office/drawing/2014/main" id="{5CCCFA7F-13DB-D954-5F20-89FE38ABC7AA}"/>
+              </a:ext>
+            </a:extLst>
+          </p:cNvPr>
+          <p:cNvCxnSpPr>
+            <a:cxnSpLocks/>
+          </p:cNvCxnSpPr>
+          <p:nvPr/>
+        </p:nvCxnSpPr>
+        <p:spPr>
+          <a:xfrm rot="10800000" flipV="1">
+            <a:off x="8136388" y="4647961"/>
+            <a:ext cx="2279630" cy="1234283"/>
+          </a:xfrm>
+          <a:prstGeom prst="bentConnector3">
+            <a:avLst>
+              <a:gd name="adj1" fmla="val -29674"/>
+            </a:avLst>
+          </a:prstGeom>
+          <a:ln>
+            <a:solidFill>
+              <a:schemeClr val="accent2"/>
+            </a:solidFill>
+            <a:tailEnd type="triangle"/>
+          </a:ln>
+        </p:spPr>
+        <p:style>
+          <a:lnRef idx="1">
+            <a:schemeClr val="accent1"/>
+          </a:lnRef>
+          <a:fillRef idx="0">
+            <a:schemeClr val="accent1"/>
+          </a:fillRef>
+          <a:effectRef idx="0">
+            <a:schemeClr val="accent1"/>
+          </a:effectRef>
+          <a:fontRef idx="minor">
+            <a:schemeClr val="tx1"/>
+          </a:fontRef>
+        </p:style>
+      </p:cxnSp>
+      <p:cxnSp>
+        <p:nvCxnSpPr>
+          <p:cNvPr id="75" name="Straight Arrow Connector 74">
+            <a:extLst>
+              <a:ext uri="{FF2B5EF4-FFF2-40B4-BE49-F238E27FC236}">
+                <a16:creationId xmlns:a16="http://schemas.microsoft.com/office/drawing/2014/main" id="{638B10A2-02E3-7441-F8D6-0840D96F9BF6}"/>
+              </a:ext>
+            </a:extLst>
+          </p:cNvPr>
+          <p:cNvCxnSpPr>
+            <a:cxnSpLocks/>
+          </p:cNvCxnSpPr>
+          <p:nvPr/>
+        </p:nvCxnSpPr>
+        <p:spPr>
+          <a:xfrm flipH="1">
+            <a:off x="7867597" y="5510256"/>
+            <a:ext cx="1271678" cy="15691"/>
+          </a:xfrm>
+          <a:prstGeom prst="straightConnector1">
+            <a:avLst/>
+          </a:prstGeom>
+          <a:ln>
+            <a:solidFill>
+              <a:schemeClr val="accent2"/>
+            </a:solidFill>
+            <a:tailEnd type="triangle"/>
+          </a:ln>
+        </p:spPr>
+        <p:style>
+          <a:lnRef idx="1">
+            <a:schemeClr val="accent1"/>
+          </a:lnRef>
+          <a:fillRef idx="0">
+            <a:schemeClr val="accent1"/>
+          </a:fillRef>
+          <a:effectRef idx="0">
+            <a:schemeClr val="accent1"/>
+          </a:effectRef>
+          <a:fontRef idx="minor">
+            <a:schemeClr val="tx1"/>
+          </a:fontRef>
+        </p:style>
+      </p:cxnSp>
+      <p:sp>
+        <p:nvSpPr>
+          <p:cNvPr id="82" name="TextBox 81">
+            <a:extLst>
+              <a:ext uri="{FF2B5EF4-FFF2-40B4-BE49-F238E27FC236}">
+                <a16:creationId xmlns:a16="http://schemas.microsoft.com/office/drawing/2014/main" id="{4A781A0F-F4DC-7C9E-1FB2-7158F21FDFFC}"/>
+              </a:ext>
+            </a:extLst>
+          </p:cNvPr>
+          <p:cNvSpPr txBox="1"/>
+          <p:nvPr/>
+        </p:nvSpPr>
+        <p:spPr>
+          <a:xfrm>
+            <a:off x="6748642" y="6601328"/>
+            <a:ext cx="1762477" cy="246221"/>
+          </a:xfrm>
+          <a:prstGeom prst="rect">
+            <a:avLst/>
+          </a:prstGeom>
+          <a:noFill/>
+        </p:spPr>
+        <p:txBody>
+          <a:bodyPr wrap="square">
+            <a:spAutoFit/>
+          </a:bodyPr>
+          <a:lstStyle/>
+          <a:p>
+            <a:r>
+              <a:rPr lang="en-US" sz="1000" noProof="1"/>
+              <a:t>$ABSOLUTE_FILE_LOCATIONS</a:t>
+            </a:r>
+          </a:p>
+        </p:txBody>
+      </p:sp>
+      <p:sp>
+        <p:nvSpPr>
+          <p:cNvPr id="85" name="TextBox 84">
+            <a:extLst>
+              <a:ext uri="{FF2B5EF4-FFF2-40B4-BE49-F238E27FC236}">
+                <a16:creationId xmlns:a16="http://schemas.microsoft.com/office/drawing/2014/main" id="{6A618C09-2663-5F67-3D91-7E50361E0D84}"/>
+              </a:ext>
+            </a:extLst>
+          </p:cNvPr>
+          <p:cNvSpPr txBox="1"/>
+          <p:nvPr/>
+        </p:nvSpPr>
+        <p:spPr>
+          <a:xfrm>
+            <a:off x="8937565" y="7133618"/>
+            <a:ext cx="2317325" cy="707886"/>
+          </a:xfrm>
+          <a:prstGeom prst="rect">
+            <a:avLst/>
+          </a:prstGeom>
+          <a:noFill/>
+        </p:spPr>
+        <p:txBody>
+          <a:bodyPr wrap="square">
+            <a:spAutoFit/>
+          </a:bodyPr>
+          <a:lstStyle/>
+          <a:p>
+            <a:r>
+              <a:rPr lang="en-US" sz="1000" noProof="1"/>
+              <a:t>$TMP/pragma-merge-running-ssh</a:t>
+            </a:r>
+          </a:p>
+          <a:p>
+            <a:r>
+              <a:rPr lang="en-US" sz="1000" noProof="1"/>
+              <a:t>(remove signaling file, </a:t>
+            </a:r>
+            <a:br>
+              <a:rPr lang="en-US" sz="1000" noProof="1"/>
+            </a:br>
+            <a:r>
+              <a:rPr lang="en-US" sz="1000" noProof="1"/>
+              <a:t>which close git difftool,</a:t>
+            </a:r>
+            <a:br>
+              <a:rPr lang="en-US" sz="1000" noProof="1"/>
+            </a:br>
+            <a:r>
+              <a:rPr lang="en-US" sz="1000" noProof="1"/>
+              <a:t>which removes temp-files)</a:t>
+            </a:r>
+            <a:endParaRPr lang="en-US" sz="1000" dirty="0"/>
+          </a:p>
+        </p:txBody>
+      </p:sp>
+      <p:grpSp>
+        <p:nvGrpSpPr>
+          <p:cNvPr id="109" name="Group 108">
+            <a:extLst>
+              <a:ext uri="{FF2B5EF4-FFF2-40B4-BE49-F238E27FC236}">
+                <a16:creationId xmlns:a16="http://schemas.microsoft.com/office/drawing/2014/main" id="{F0CD306D-9270-4B65-82C0-765ABFC09271}"/>
+              </a:ext>
+            </a:extLst>
+          </p:cNvPr>
+          <p:cNvGrpSpPr/>
+          <p:nvPr/>
+        </p:nvGrpSpPr>
+        <p:grpSpPr>
+          <a:xfrm>
+            <a:off x="9029193" y="7201954"/>
+            <a:ext cx="1796511" cy="122851"/>
+            <a:chOff x="6875510" y="8853970"/>
+            <a:chExt cx="1796511" cy="122851"/>
+          </a:xfrm>
+        </p:grpSpPr>
+        <p:cxnSp>
+          <p:nvCxnSpPr>
+            <p:cNvPr id="87" name="Straight Connector 86">
+              <a:extLst>
+                <a:ext uri="{FF2B5EF4-FFF2-40B4-BE49-F238E27FC236}">
+                  <a16:creationId xmlns:a16="http://schemas.microsoft.com/office/drawing/2014/main" id="{A24F06F0-49FF-E61B-3D5F-2AC786B3394B}"/>
+                </a:ext>
+              </a:extLst>
+            </p:cNvPr>
+            <p:cNvCxnSpPr>
+              <a:cxnSpLocks/>
+            </p:cNvCxnSpPr>
+            <p:nvPr/>
+          </p:nvCxnSpPr>
+          <p:spPr>
+            <a:xfrm>
+              <a:off x="6875510" y="8853970"/>
+              <a:ext cx="1796511" cy="122851"/>
+            </a:xfrm>
+            <a:prstGeom prst="line">
+              <a:avLst/>
+            </a:prstGeom>
+            <a:ln>
+              <a:solidFill>
+                <a:srgbClr val="FF0000"/>
+              </a:solidFill>
+            </a:ln>
+          </p:spPr>
+          <p:style>
+            <a:lnRef idx="1">
+              <a:schemeClr val="accent2"/>
+            </a:lnRef>
+            <a:fillRef idx="0">
+              <a:schemeClr val="accent2"/>
+            </a:fillRef>
+            <a:effectRef idx="0">
+              <a:schemeClr val="accent2"/>
+            </a:effectRef>
+            <a:fontRef idx="minor">
+              <a:schemeClr val="tx1"/>
+            </a:fontRef>
+          </p:style>
+        </p:cxnSp>
+        <p:cxnSp>
+          <p:nvCxnSpPr>
+            <p:cNvPr id="88" name="Straight Connector 87">
+              <a:extLst>
+                <a:ext uri="{FF2B5EF4-FFF2-40B4-BE49-F238E27FC236}">
+                  <a16:creationId xmlns:a16="http://schemas.microsoft.com/office/drawing/2014/main" id="{B4E50141-491C-C131-7192-8561BF572BE0}"/>
+                </a:ext>
+              </a:extLst>
+            </p:cNvPr>
+            <p:cNvCxnSpPr>
+              <a:cxnSpLocks/>
+            </p:cNvCxnSpPr>
+            <p:nvPr/>
+          </p:nvCxnSpPr>
+          <p:spPr>
+            <a:xfrm flipV="1">
+              <a:off x="6890075" y="8853970"/>
+              <a:ext cx="1696517" cy="122851"/>
+            </a:xfrm>
+            <a:prstGeom prst="line">
+              <a:avLst/>
+            </a:prstGeom>
+            <a:ln>
+              <a:solidFill>
+                <a:srgbClr val="FF0000"/>
+              </a:solidFill>
+            </a:ln>
+          </p:spPr>
+          <p:style>
+            <a:lnRef idx="1">
+              <a:schemeClr val="accent2"/>
+            </a:lnRef>
+            <a:fillRef idx="0">
+              <a:schemeClr val="accent2"/>
+            </a:fillRef>
+            <a:effectRef idx="0">
+              <a:schemeClr val="accent2"/>
+            </a:effectRef>
+            <a:fontRef idx="minor">
+              <a:schemeClr val="tx1"/>
+            </a:fontRef>
+          </p:style>
+        </p:cxnSp>
+      </p:grpSp>
+      <p:cxnSp>
+        <p:nvCxnSpPr>
+          <p:cNvPr id="90" name="Straight Arrow Connector 89">
+            <a:extLst>
+              <a:ext uri="{FF2B5EF4-FFF2-40B4-BE49-F238E27FC236}">
+                <a16:creationId xmlns:a16="http://schemas.microsoft.com/office/drawing/2014/main" id="{9CA630EE-0C17-1BD7-CA20-1BFFF039B2D7}"/>
+              </a:ext>
+            </a:extLst>
+          </p:cNvPr>
+          <p:cNvCxnSpPr>
+            <a:cxnSpLocks/>
+          </p:cNvCxnSpPr>
+          <p:nvPr/>
+        </p:nvCxnSpPr>
+        <p:spPr>
+          <a:xfrm flipV="1">
+            <a:off x="7998776" y="7248660"/>
+            <a:ext cx="912866" cy="8146"/>
+          </a:xfrm>
+          <a:prstGeom prst="straightConnector1">
+            <a:avLst/>
+          </a:prstGeom>
+          <a:ln>
+            <a:solidFill>
+              <a:schemeClr val="accent2"/>
+            </a:solidFill>
+            <a:tailEnd type="triangle"/>
+          </a:ln>
+        </p:spPr>
+        <p:style>
+          <a:lnRef idx="1">
+            <a:schemeClr val="accent1"/>
+          </a:lnRef>
+          <a:fillRef idx="0">
+            <a:schemeClr val="accent1"/>
+          </a:fillRef>
+          <a:effectRef idx="0">
+            <a:schemeClr val="accent1"/>
+          </a:effectRef>
+          <a:fontRef idx="minor">
+            <a:schemeClr val="tx1"/>
+          </a:fontRef>
+        </p:style>
+      </p:cxnSp>
+      <p:sp>
+        <p:nvSpPr>
+          <p:cNvPr id="92" name="TextBox 91">
+            <a:extLst>
+              <a:ext uri="{FF2B5EF4-FFF2-40B4-BE49-F238E27FC236}">
+                <a16:creationId xmlns:a16="http://schemas.microsoft.com/office/drawing/2014/main" id="{258CDA59-4306-7694-39FE-F77F19A86D31}"/>
+              </a:ext>
+            </a:extLst>
+          </p:cNvPr>
+          <p:cNvSpPr txBox="1"/>
+          <p:nvPr/>
+        </p:nvSpPr>
+        <p:spPr>
+          <a:xfrm>
+            <a:off x="6742370" y="5990542"/>
+            <a:ext cx="1906068" cy="400110"/>
+          </a:xfrm>
+          <a:prstGeom prst="rect">
+            <a:avLst/>
+          </a:prstGeom>
+          <a:noFill/>
+        </p:spPr>
+        <p:txBody>
+          <a:bodyPr wrap="square">
+            <a:spAutoFit/>
+          </a:bodyPr>
+          <a:lstStyle/>
+          <a:p>
+            <a:r>
+              <a:rPr lang="en-US" sz="1000" noProof="1"/>
+              <a:t>Make absolute paths of these in </a:t>
+            </a:r>
+            <a:br>
+              <a:rPr lang="en-US" sz="1000" noProof="1"/>
+            </a:br>
+            <a:r>
+              <a:rPr lang="en-US" sz="1000" noProof="1"/>
+              <a:t>$ABSOLUTE_FILE_LOCATIONS</a:t>
+            </a:r>
+          </a:p>
+        </p:txBody>
+      </p:sp>
+      <p:cxnSp>
+        <p:nvCxnSpPr>
+          <p:cNvPr id="110" name="Straight Arrow Connector 109">
+            <a:extLst>
+              <a:ext uri="{FF2B5EF4-FFF2-40B4-BE49-F238E27FC236}">
+                <a16:creationId xmlns:a16="http://schemas.microsoft.com/office/drawing/2014/main" id="{ED05C266-01F6-F76D-D8F4-B73A83F678E7}"/>
+              </a:ext>
+            </a:extLst>
+          </p:cNvPr>
+          <p:cNvCxnSpPr>
+            <a:cxnSpLocks/>
+          </p:cNvCxnSpPr>
+          <p:nvPr/>
+        </p:nvCxnSpPr>
+        <p:spPr>
+          <a:xfrm flipV="1">
+            <a:off x="8136388" y="4220299"/>
+            <a:ext cx="635279" cy="98471"/>
+          </a:xfrm>
+          <a:prstGeom prst="straightConnector1">
+            <a:avLst/>
+          </a:prstGeom>
+          <a:ln>
+            <a:tailEnd type="triangle"/>
+          </a:ln>
+        </p:spPr>
+        <p:style>
+          <a:lnRef idx="1">
+            <a:schemeClr val="accent1"/>
+          </a:lnRef>
+          <a:fillRef idx="0">
+            <a:schemeClr val="accent1"/>
+          </a:fillRef>
+          <a:effectRef idx="0">
+            <a:schemeClr val="accent1"/>
+          </a:effectRef>
+          <a:fontRef idx="minor">
+            <a:schemeClr val="tx1"/>
+          </a:fontRef>
+        </p:style>
+      </p:cxnSp>
+      <p:cxnSp>
+        <p:nvCxnSpPr>
+          <p:cNvPr id="116" name="Straight Arrow Connector 115">
+            <a:extLst>
+              <a:ext uri="{FF2B5EF4-FFF2-40B4-BE49-F238E27FC236}">
+                <a16:creationId xmlns:a16="http://schemas.microsoft.com/office/drawing/2014/main" id="{2C06213A-570A-2B83-9122-ABF77924BFCA}"/>
+              </a:ext>
+            </a:extLst>
+          </p:cNvPr>
+          <p:cNvCxnSpPr>
+            <a:cxnSpLocks/>
+          </p:cNvCxnSpPr>
+          <p:nvPr/>
+        </p:nvCxnSpPr>
+        <p:spPr>
+          <a:xfrm>
+            <a:off x="6470853" y="7747611"/>
+            <a:ext cx="247820" cy="0"/>
+          </a:xfrm>
+          <a:prstGeom prst="straightConnector1">
+            <a:avLst/>
+          </a:prstGeom>
+          <a:ln>
+            <a:tailEnd type="triangle"/>
+          </a:ln>
+        </p:spPr>
+        <p:style>
+          <a:lnRef idx="1">
+            <a:schemeClr val="accent1"/>
+          </a:lnRef>
+          <a:fillRef idx="0">
+            <a:schemeClr val="accent1"/>
+          </a:fillRef>
+          <a:effectRef idx="0">
+            <a:schemeClr val="accent1"/>
+          </a:effectRef>
+          <a:fontRef idx="minor">
+            <a:schemeClr val="tx1"/>
+          </a:fontRef>
+        </p:style>
+      </p:cxnSp>
+      <p:cxnSp>
+        <p:nvCxnSpPr>
+          <p:cNvPr id="118" name="Straight Arrow Connector 117">
+            <a:extLst>
+              <a:ext uri="{FF2B5EF4-FFF2-40B4-BE49-F238E27FC236}">
+                <a16:creationId xmlns:a16="http://schemas.microsoft.com/office/drawing/2014/main" id="{84AE73E9-94DA-8070-100A-50CBB784CFA3}"/>
+              </a:ext>
+            </a:extLst>
+          </p:cNvPr>
+          <p:cNvCxnSpPr>
+            <a:cxnSpLocks/>
+          </p:cNvCxnSpPr>
+          <p:nvPr/>
+        </p:nvCxnSpPr>
+        <p:spPr>
+          <a:xfrm>
+            <a:off x="6483578" y="7900262"/>
+            <a:ext cx="252358" cy="0"/>
+          </a:xfrm>
+          <a:prstGeom prst="straightConnector1">
+            <a:avLst/>
+          </a:prstGeom>
+          <a:ln>
+            <a:solidFill>
+              <a:schemeClr val="accent2"/>
+            </a:solidFill>
+            <a:tailEnd type="triangle"/>
+          </a:ln>
+        </p:spPr>
+        <p:style>
+          <a:lnRef idx="1">
+            <a:schemeClr val="accent1"/>
+          </a:lnRef>
+          <a:fillRef idx="0">
+            <a:schemeClr val="accent1"/>
+          </a:fillRef>
+          <a:effectRef idx="0">
+            <a:schemeClr val="accent1"/>
+          </a:effectRef>
+          <a:fontRef idx="minor">
+            <a:schemeClr val="tx1"/>
+          </a:fontRef>
+        </p:style>
+      </p:cxnSp>
+      <p:sp>
+        <p:nvSpPr>
+          <p:cNvPr id="121" name="TextBox 120">
+            <a:extLst>
+              <a:ext uri="{FF2B5EF4-FFF2-40B4-BE49-F238E27FC236}">
+                <a16:creationId xmlns:a16="http://schemas.microsoft.com/office/drawing/2014/main" id="{8D66560C-3E53-AE28-C998-53DE7641AE5E}"/>
+              </a:ext>
+            </a:extLst>
+          </p:cNvPr>
+          <p:cNvSpPr txBox="1"/>
+          <p:nvPr/>
+        </p:nvSpPr>
+        <p:spPr>
+          <a:xfrm>
+            <a:off x="6687254" y="7619678"/>
+            <a:ext cx="1039841" cy="400110"/>
+          </a:xfrm>
+          <a:prstGeom prst="rect">
+            <a:avLst/>
+          </a:prstGeom>
+          <a:noFill/>
+        </p:spPr>
+        <p:txBody>
+          <a:bodyPr wrap="square">
+            <a:spAutoFit/>
+          </a:bodyPr>
+          <a:lstStyle/>
+          <a:p>
+            <a:r>
+              <a:rPr lang="en-US" sz="1000" noProof="1">
+                <a:solidFill>
+                  <a:schemeClr val="accent1"/>
+                </a:solidFill>
+              </a:rPr>
+              <a:t>commands</a:t>
+            </a:r>
+          </a:p>
+          <a:p>
+            <a:r>
+              <a:rPr lang="en-US" sz="1000" noProof="1">
+                <a:solidFill>
+                  <a:schemeClr val="accent1"/>
+                </a:solidFill>
+              </a:rPr>
+              <a:t>file operations</a:t>
+            </a:r>
+            <a:endParaRPr lang="en-US" sz="1000" dirty="0"/>
+          </a:p>
+        </p:txBody>
+      </p:sp>
+      <p:sp>
+        <p:nvSpPr>
+          <p:cNvPr id="123" name="TextBox 122">
+            <a:extLst>
+              <a:ext uri="{FF2B5EF4-FFF2-40B4-BE49-F238E27FC236}">
+                <a16:creationId xmlns:a16="http://schemas.microsoft.com/office/drawing/2014/main" id="{E906DC65-386F-A065-C39D-E8F9213D6FA3}"/>
+              </a:ext>
+            </a:extLst>
+          </p:cNvPr>
+          <p:cNvSpPr txBox="1"/>
+          <p:nvPr/>
+        </p:nvSpPr>
+        <p:spPr>
+          <a:xfrm>
+            <a:off x="10554968" y="4039443"/>
+            <a:ext cx="370614" cy="369332"/>
+          </a:xfrm>
+          <a:prstGeom prst="rect">
+            <a:avLst/>
+          </a:prstGeom>
+          <a:noFill/>
+        </p:spPr>
+        <p:txBody>
+          <a:bodyPr wrap="none" rtlCol="0">
+            <a:spAutoFit/>
+          </a:bodyPr>
+          <a:lstStyle/>
+          <a:p>
+            <a:r>
+              <a:rPr lang="en-US" dirty="0"/>
+              <a:t>*)</a:t>
+            </a:r>
+          </a:p>
+        </p:txBody>
+      </p:sp>
+      <p:sp>
+        <p:nvSpPr>
+          <p:cNvPr id="124" name="TextBox 123">
+            <a:extLst>
+              <a:ext uri="{FF2B5EF4-FFF2-40B4-BE49-F238E27FC236}">
+                <a16:creationId xmlns:a16="http://schemas.microsoft.com/office/drawing/2014/main" id="{A3A75491-E066-021D-9B1B-CCADDB40C015}"/>
+              </a:ext>
+            </a:extLst>
+          </p:cNvPr>
+          <p:cNvSpPr txBox="1"/>
+          <p:nvPr/>
+        </p:nvSpPr>
+        <p:spPr>
+          <a:xfrm>
+            <a:off x="6193794" y="8117958"/>
+            <a:ext cx="5484041" cy="400110"/>
+          </a:xfrm>
+          <a:prstGeom prst="rect">
+            <a:avLst/>
+          </a:prstGeom>
+          <a:noFill/>
+        </p:spPr>
+        <p:txBody>
+          <a:bodyPr wrap="square">
+            <a:spAutoFit/>
+          </a:bodyPr>
+          <a:lstStyle/>
+          <a:p>
+            <a:r>
+              <a:rPr lang="en-US" sz="1000" noProof="1"/>
+              <a:t>*)  NOTE, git difftool waits until pragma-merge is closed. That’s why I start a delayed local</a:t>
+            </a:r>
+          </a:p>
+          <a:p>
+            <a:r>
+              <a:rPr lang="en-US" sz="1000" noProof="1"/>
+              <a:t> pick-up of files -- to give server difftool time to generate BASE, … .</a:t>
+            </a:r>
+            <a:endParaRPr lang="en-US" sz="1000" dirty="0"/>
+          </a:p>
+        </p:txBody>
+      </p:sp>
+      <p:sp>
+        <p:nvSpPr>
+          <p:cNvPr id="125" name="TextBox 124">
+            <a:extLst>
+              <a:ext uri="{FF2B5EF4-FFF2-40B4-BE49-F238E27FC236}">
+                <a16:creationId xmlns:a16="http://schemas.microsoft.com/office/drawing/2014/main" id="{6EC5E2B6-56D8-2950-2989-2CA956431A57}"/>
+              </a:ext>
+            </a:extLst>
+          </p:cNvPr>
+          <p:cNvSpPr txBox="1"/>
+          <p:nvPr/>
+        </p:nvSpPr>
+        <p:spPr>
+          <a:xfrm>
+            <a:off x="7972947" y="4546745"/>
+            <a:ext cx="370614" cy="369332"/>
+          </a:xfrm>
+          <a:prstGeom prst="rect">
+            <a:avLst/>
+          </a:prstGeom>
+          <a:noFill/>
+        </p:spPr>
+        <p:txBody>
+          <a:bodyPr wrap="none" rtlCol="0">
+            <a:spAutoFit/>
+          </a:bodyPr>
+          <a:lstStyle/>
+          <a:p>
+            <a:r>
+              <a:rPr lang="en-US" dirty="0"/>
+              <a:t>*)</a:t>
+            </a:r>
+          </a:p>
+        </p:txBody>
+      </p:sp>
+      <p:cxnSp>
+        <p:nvCxnSpPr>
+          <p:cNvPr id="148" name="Elbow Connector 147">
+            <a:extLst>
+              <a:ext uri="{FF2B5EF4-FFF2-40B4-BE49-F238E27FC236}">
+                <a16:creationId xmlns:a16="http://schemas.microsoft.com/office/drawing/2014/main" id="{E2C22964-1A79-DF6F-11CB-AA2ED2389F3B}"/>
+              </a:ext>
+            </a:extLst>
+          </p:cNvPr>
+          <p:cNvCxnSpPr>
+            <a:cxnSpLocks/>
+          </p:cNvCxnSpPr>
+          <p:nvPr/>
+        </p:nvCxnSpPr>
+        <p:spPr>
+          <a:xfrm rot="10800000" flipH="1" flipV="1">
+            <a:off x="6398112" y="4219283"/>
+            <a:ext cx="61298" cy="504725"/>
+          </a:xfrm>
+          <a:prstGeom prst="bentConnector3">
+            <a:avLst>
+              <a:gd name="adj1" fmla="val -372932"/>
+            </a:avLst>
+          </a:prstGeom>
+          <a:ln>
+            <a:tailEnd type="triangle"/>
+          </a:ln>
+        </p:spPr>
+        <p:style>
+          <a:lnRef idx="1">
+            <a:schemeClr val="accent1"/>
+          </a:lnRef>
+          <a:fillRef idx="0">
+            <a:schemeClr val="accent1"/>
+          </a:fillRef>
+          <a:effectRef idx="0">
+            <a:schemeClr val="accent1"/>
+          </a:effectRef>
+          <a:fontRef idx="minor">
+            <a:schemeClr val="tx1"/>
+          </a:fontRef>
+        </p:style>
+      </p:cxnSp>
+      <p:sp>
+        <p:nvSpPr>
+          <p:cNvPr id="152" name="TextBox 151">
+            <a:extLst>
+              <a:ext uri="{FF2B5EF4-FFF2-40B4-BE49-F238E27FC236}">
+                <a16:creationId xmlns:a16="http://schemas.microsoft.com/office/drawing/2014/main" id="{F71DA6D7-CCD9-ADBB-97CA-8528B218DF66}"/>
+              </a:ext>
+            </a:extLst>
+          </p:cNvPr>
+          <p:cNvSpPr txBox="1"/>
+          <p:nvPr/>
+        </p:nvSpPr>
+        <p:spPr>
+          <a:xfrm>
+            <a:off x="6886416" y="5026821"/>
+            <a:ext cx="696003" cy="246221"/>
+          </a:xfrm>
+          <a:prstGeom prst="rect">
+            <a:avLst/>
+          </a:prstGeom>
+          <a:noFill/>
+        </p:spPr>
+        <p:txBody>
+          <a:bodyPr wrap="square">
+            <a:spAutoFit/>
+          </a:bodyPr>
+          <a:lstStyle/>
+          <a:p>
+            <a:r>
+              <a:rPr lang="en-US" sz="1000" noProof="1">
+                <a:solidFill>
+                  <a:schemeClr val="accent1"/>
+                </a:solidFill>
+              </a:rPr>
+              <a:t>(wait 2 s)</a:t>
+            </a:r>
+            <a:endParaRPr lang="en-US" sz="1000" dirty="0"/>
+          </a:p>
+        </p:txBody>
+      </p:sp>
+      <p:sp>
+        <p:nvSpPr>
+          <p:cNvPr id="154" name="Right Brace 153">
+            <a:extLst>
+              <a:ext uri="{FF2B5EF4-FFF2-40B4-BE49-F238E27FC236}">
+                <a16:creationId xmlns:a16="http://schemas.microsoft.com/office/drawing/2014/main" id="{8581082B-D67F-93AE-F34A-EE44EE6041E9}"/>
+              </a:ext>
+            </a:extLst>
+          </p:cNvPr>
+          <p:cNvSpPr/>
+          <p:nvPr/>
+        </p:nvSpPr>
+        <p:spPr>
+          <a:xfrm>
+            <a:off x="10232136" y="4496533"/>
+            <a:ext cx="138162" cy="393374"/>
+          </a:xfrm>
+          <a:prstGeom prst="rightBrace">
+            <a:avLst/>
+          </a:prstGeom>
+        </p:spPr>
+        <p:style>
+          <a:lnRef idx="1">
+            <a:schemeClr val="accent1"/>
+          </a:lnRef>
+          <a:fillRef idx="0">
+            <a:schemeClr val="accent1"/>
+          </a:fillRef>
+          <a:effectRef idx="0">
+            <a:schemeClr val="accent1"/>
+          </a:effectRef>
+          <a:fontRef idx="minor">
+            <a:schemeClr val="tx1"/>
+          </a:fontRef>
+        </p:style>
+        <p:txBody>
+          <a:bodyPr rtlCol="0" anchor="ctr"/>
+          <a:lstStyle/>
+          <a:p>
+            <a:pPr algn="ctr"/>
+            <a:endParaRPr lang="en-US"/>
           </a:p>
         </p:txBody>
       </p:sp>

</xml_diff>

<commit_message>
ssh-folder -- refactor, add : put, get
rename ssh-pragma-merge-files -> ssh-get-merge-files
test-script for ssh-functions
</commit_message>
<xml_diff>
--- a/docs/Tech-overview.pptx
+++ b/docs/Tech-overview.pptx
@@ -264,7 +264,7 @@
           <a:p>
             <a:fld id="{CA855E1B-8830-B64E-B102-DB2BBD0D9567}" type="datetimeFigureOut">
               <a:rPr lang="sv-SE" smtClean="0"/>
-              <a:t>2025-05-23</a:t>
+              <a:t>2025-05-30</a:t>
             </a:fld>
             <a:endParaRPr lang="sv-SE"/>
           </a:p>
@@ -434,7 +434,7 @@
           <a:p>
             <a:fld id="{CA855E1B-8830-B64E-B102-DB2BBD0D9567}" type="datetimeFigureOut">
               <a:rPr lang="sv-SE" smtClean="0"/>
-              <a:t>2025-05-23</a:t>
+              <a:t>2025-05-30</a:t>
             </a:fld>
             <a:endParaRPr lang="sv-SE"/>
           </a:p>
@@ -614,7 +614,7 @@
           <a:p>
             <a:fld id="{CA855E1B-8830-B64E-B102-DB2BBD0D9567}" type="datetimeFigureOut">
               <a:rPr lang="sv-SE" smtClean="0"/>
-              <a:t>2025-05-23</a:t>
+              <a:t>2025-05-30</a:t>
             </a:fld>
             <a:endParaRPr lang="sv-SE"/>
           </a:p>
@@ -784,7 +784,7 @@
           <a:p>
             <a:fld id="{CA855E1B-8830-B64E-B102-DB2BBD0D9567}" type="datetimeFigureOut">
               <a:rPr lang="sv-SE" smtClean="0"/>
-              <a:t>2025-05-23</a:t>
+              <a:t>2025-05-30</a:t>
             </a:fld>
             <a:endParaRPr lang="sv-SE"/>
           </a:p>
@@ -1028,7 +1028,7 @@
           <a:p>
             <a:fld id="{CA855E1B-8830-B64E-B102-DB2BBD0D9567}" type="datetimeFigureOut">
               <a:rPr lang="sv-SE" smtClean="0"/>
-              <a:t>2025-05-23</a:t>
+              <a:t>2025-05-30</a:t>
             </a:fld>
             <a:endParaRPr lang="sv-SE"/>
           </a:p>
@@ -1260,7 +1260,7 @@
           <a:p>
             <a:fld id="{CA855E1B-8830-B64E-B102-DB2BBD0D9567}" type="datetimeFigureOut">
               <a:rPr lang="sv-SE" smtClean="0"/>
-              <a:t>2025-05-23</a:t>
+              <a:t>2025-05-30</a:t>
             </a:fld>
             <a:endParaRPr lang="sv-SE"/>
           </a:p>
@@ -1627,7 +1627,7 @@
           <a:p>
             <a:fld id="{CA855E1B-8830-B64E-B102-DB2BBD0D9567}" type="datetimeFigureOut">
               <a:rPr lang="sv-SE" smtClean="0"/>
-              <a:t>2025-05-23</a:t>
+              <a:t>2025-05-30</a:t>
             </a:fld>
             <a:endParaRPr lang="sv-SE"/>
           </a:p>
@@ -1745,7 +1745,7 @@
           <a:p>
             <a:fld id="{CA855E1B-8830-B64E-B102-DB2BBD0D9567}" type="datetimeFigureOut">
               <a:rPr lang="sv-SE" smtClean="0"/>
-              <a:t>2025-05-23</a:t>
+              <a:t>2025-05-30</a:t>
             </a:fld>
             <a:endParaRPr lang="sv-SE"/>
           </a:p>
@@ -1840,7 +1840,7 @@
           <a:p>
             <a:fld id="{CA855E1B-8830-B64E-B102-DB2BBD0D9567}" type="datetimeFigureOut">
               <a:rPr lang="sv-SE" smtClean="0"/>
-              <a:t>2025-05-23</a:t>
+              <a:t>2025-05-30</a:t>
             </a:fld>
             <a:endParaRPr lang="sv-SE"/>
           </a:p>
@@ -2117,7 +2117,7 @@
           <a:p>
             <a:fld id="{CA855E1B-8830-B64E-B102-DB2BBD0D9567}" type="datetimeFigureOut">
               <a:rPr lang="sv-SE" smtClean="0"/>
-              <a:t>2025-05-23</a:t>
+              <a:t>2025-05-30</a:t>
             </a:fld>
             <a:endParaRPr lang="sv-SE"/>
           </a:p>
@@ -2374,7 +2374,7 @@
           <a:p>
             <a:fld id="{CA855E1B-8830-B64E-B102-DB2BBD0D9567}" type="datetimeFigureOut">
               <a:rPr lang="sv-SE" smtClean="0"/>
-              <a:t>2025-05-23</a:t>
+              <a:t>2025-05-30</a:t>
             </a:fld>
             <a:endParaRPr lang="sv-SE"/>
           </a:p>
@@ -2587,7 +2587,7 @@
           <a:p>
             <a:fld id="{CA855E1B-8830-B64E-B102-DB2BBD0D9567}" type="datetimeFigureOut">
               <a:rPr lang="sv-SE" smtClean="0"/>
-              <a:t>2025-05-23</a:t>
+              <a:t>2025-05-30</a:t>
             </a:fld>
             <a:endParaRPr lang="sv-SE"/>
           </a:p>
@@ -14493,7 +14493,7 @@
             </a:pPr>
             <a:r>
               <a:rPr lang="en-US" sz="800" noProof="1"/>
-              <a:t>Start ssh-pragma-merge-files, to pick up files from server</a:t>
+              <a:t>Start ssh-get-merge-files, to pick up files from server</a:t>
             </a:r>
           </a:p>
           <a:p>
@@ -14518,7 +14518,7 @@
                   <a:schemeClr val="accent1"/>
                 </a:solidFill>
               </a:rPr>
-              <a:t>-&gt; CLIENT; ssh-pragma-merge-files – </a:t>
+              <a:t>-&gt; CLIENT; ssh-get-merge-files – </a:t>
             </a:r>
             <a:r>
               <a:rPr lang="en-US" sz="800" noProof="1"/>
@@ -15020,7 +15020,7 @@
                   <a:schemeClr val="accent1"/>
                 </a:solidFill>
               </a:rPr>
-              <a:t>ssh-pragma-merge-files</a:t>
+              <a:t>ssh-get-merge-files</a:t>
             </a:r>
             <a:endParaRPr lang="en-US" sz="1000" dirty="0"/>
           </a:p>

</xml_diff>

<commit_message>
implement fs_existsSync -- check if file exist for both ssh and local
</commit_message>
<xml_diff>
--- a/docs/Tech-overview.pptx
+++ b/docs/Tech-overview.pptx
@@ -264,7 +264,7 @@
           <a:p>
             <a:fld id="{CA855E1B-8830-B64E-B102-DB2BBD0D9567}" type="datetimeFigureOut">
               <a:rPr lang="sv-SE" smtClean="0"/>
-              <a:t>2025-05-30</a:t>
+              <a:t>2025-06-04</a:t>
             </a:fld>
             <a:endParaRPr lang="sv-SE"/>
           </a:p>
@@ -434,7 +434,7 @@
           <a:p>
             <a:fld id="{CA855E1B-8830-B64E-B102-DB2BBD0D9567}" type="datetimeFigureOut">
               <a:rPr lang="sv-SE" smtClean="0"/>
-              <a:t>2025-05-30</a:t>
+              <a:t>2025-06-04</a:t>
             </a:fld>
             <a:endParaRPr lang="sv-SE"/>
           </a:p>
@@ -614,7 +614,7 @@
           <a:p>
             <a:fld id="{CA855E1B-8830-B64E-B102-DB2BBD0D9567}" type="datetimeFigureOut">
               <a:rPr lang="sv-SE" smtClean="0"/>
-              <a:t>2025-05-30</a:t>
+              <a:t>2025-06-04</a:t>
             </a:fld>
             <a:endParaRPr lang="sv-SE"/>
           </a:p>
@@ -784,7 +784,7 @@
           <a:p>
             <a:fld id="{CA855E1B-8830-B64E-B102-DB2BBD0D9567}" type="datetimeFigureOut">
               <a:rPr lang="sv-SE" smtClean="0"/>
-              <a:t>2025-05-30</a:t>
+              <a:t>2025-06-04</a:t>
             </a:fld>
             <a:endParaRPr lang="sv-SE"/>
           </a:p>
@@ -1028,7 +1028,7 @@
           <a:p>
             <a:fld id="{CA855E1B-8830-B64E-B102-DB2BBD0D9567}" type="datetimeFigureOut">
               <a:rPr lang="sv-SE" smtClean="0"/>
-              <a:t>2025-05-30</a:t>
+              <a:t>2025-06-04</a:t>
             </a:fld>
             <a:endParaRPr lang="sv-SE"/>
           </a:p>
@@ -1260,7 +1260,7 @@
           <a:p>
             <a:fld id="{CA855E1B-8830-B64E-B102-DB2BBD0D9567}" type="datetimeFigureOut">
               <a:rPr lang="sv-SE" smtClean="0"/>
-              <a:t>2025-05-30</a:t>
+              <a:t>2025-06-04</a:t>
             </a:fld>
             <a:endParaRPr lang="sv-SE"/>
           </a:p>
@@ -1627,7 +1627,7 @@
           <a:p>
             <a:fld id="{CA855E1B-8830-B64E-B102-DB2BBD0D9567}" type="datetimeFigureOut">
               <a:rPr lang="sv-SE" smtClean="0"/>
-              <a:t>2025-05-30</a:t>
+              <a:t>2025-06-04</a:t>
             </a:fld>
             <a:endParaRPr lang="sv-SE"/>
           </a:p>
@@ -1745,7 +1745,7 @@
           <a:p>
             <a:fld id="{CA855E1B-8830-B64E-B102-DB2BBD0D9567}" type="datetimeFigureOut">
               <a:rPr lang="sv-SE" smtClean="0"/>
-              <a:t>2025-05-30</a:t>
+              <a:t>2025-06-04</a:t>
             </a:fld>
             <a:endParaRPr lang="sv-SE"/>
           </a:p>
@@ -1840,7 +1840,7 @@
           <a:p>
             <a:fld id="{CA855E1B-8830-B64E-B102-DB2BBD0D9567}" type="datetimeFigureOut">
               <a:rPr lang="sv-SE" smtClean="0"/>
-              <a:t>2025-05-30</a:t>
+              <a:t>2025-06-04</a:t>
             </a:fld>
             <a:endParaRPr lang="sv-SE"/>
           </a:p>
@@ -2117,7 +2117,7 @@
           <a:p>
             <a:fld id="{CA855E1B-8830-B64E-B102-DB2BBD0D9567}" type="datetimeFigureOut">
               <a:rPr lang="sv-SE" smtClean="0"/>
-              <a:t>2025-05-30</a:t>
+              <a:t>2025-06-04</a:t>
             </a:fld>
             <a:endParaRPr lang="sv-SE"/>
           </a:p>
@@ -2374,7 +2374,7 @@
           <a:p>
             <a:fld id="{CA855E1B-8830-B64E-B102-DB2BBD0D9567}" type="datetimeFigureOut">
               <a:rPr lang="sv-SE" smtClean="0"/>
-              <a:t>2025-05-30</a:t>
+              <a:t>2025-06-04</a:t>
             </a:fld>
             <a:endParaRPr lang="sv-SE"/>
           </a:p>
@@ -2587,7 +2587,7 @@
           <a:p>
             <a:fld id="{CA855E1B-8830-B64E-B102-DB2BBD0D9567}" type="datetimeFigureOut">
               <a:rPr lang="sv-SE" smtClean="0"/>
-              <a:t>2025-05-30</a:t>
+              <a:t>2025-06-04</a:t>
             </a:fld>
             <a:endParaRPr lang="sv-SE"/>
           </a:p>
@@ -14202,7 +14202,7 @@
         <p:spPr>
           <a:xfrm>
             <a:off x="336553" y="953256"/>
-            <a:ext cx="1829155" cy="461665"/>
+            <a:ext cx="2351734" cy="461665"/>
           </a:xfrm>
           <a:prstGeom prst="rect">
             <a:avLst/>
@@ -14217,7 +14217,7 @@
           <a:p>
             <a:r>
               <a:rPr lang="en-US" sz="2400" b="1" noProof="1"/>
-              <a:t>Git on server</a:t>
+              <a:t>Run git on server</a:t>
             </a:r>
           </a:p>
         </p:txBody>
@@ -16227,6 +16227,150 @@
           <a:p>
             <a:pPr algn="ctr"/>
             <a:endParaRPr lang="en-US"/>
+          </a:p>
+        </p:txBody>
+      </p:sp>
+      <p:sp>
+        <p:nvSpPr>
+          <p:cNvPr id="3" name="textruta 5">
+            <a:extLst>
+              <a:ext uri="{FF2B5EF4-FFF2-40B4-BE49-F238E27FC236}">
+                <a16:creationId xmlns:a16="http://schemas.microsoft.com/office/drawing/2014/main" id="{DCD37A85-53A7-04DE-FAA1-BB7E94E9B34E}"/>
+              </a:ext>
+            </a:extLst>
+          </p:cNvPr>
+          <p:cNvSpPr txBox="1"/>
+          <p:nvPr/>
+        </p:nvSpPr>
+        <p:spPr>
+          <a:xfrm>
+            <a:off x="4651737" y="947704"/>
+            <a:ext cx="6694077" cy="461665"/>
+          </a:xfrm>
+          <a:prstGeom prst="rect">
+            <a:avLst/>
+          </a:prstGeom>
+          <a:noFill/>
+        </p:spPr>
+        <p:txBody>
+          <a:bodyPr wrap="none" rtlCol="0">
+            <a:spAutoFit/>
+          </a:bodyPr>
+          <a:lstStyle/>
+          <a:p>
+            <a:r>
+              <a:rPr lang="en-US" sz="2400" b="1" noProof="1"/>
+              <a:t>File operations that works locally and on ssh server</a:t>
+            </a:r>
+          </a:p>
+        </p:txBody>
+      </p:sp>
+      <p:sp>
+        <p:nvSpPr>
+          <p:cNvPr id="7" name="textruta 4">
+            <a:extLst>
+              <a:ext uri="{FF2B5EF4-FFF2-40B4-BE49-F238E27FC236}">
+                <a16:creationId xmlns:a16="http://schemas.microsoft.com/office/drawing/2014/main" id="{FF3C9341-A2A2-DB9D-5BC3-402F8F43647B}"/>
+              </a:ext>
+            </a:extLst>
+          </p:cNvPr>
+          <p:cNvSpPr txBox="1"/>
+          <p:nvPr/>
+        </p:nvSpPr>
+        <p:spPr>
+          <a:xfrm>
+            <a:off x="4813121" y="1521282"/>
+            <a:ext cx="5927153" cy="954107"/>
+          </a:xfrm>
+          <a:prstGeom prst="rect">
+            <a:avLst/>
+          </a:prstGeom>
+          <a:noFill/>
+          <a:ln>
+            <a:solidFill>
+              <a:schemeClr val="accent1"/>
+            </a:solidFill>
+          </a:ln>
+        </p:spPr>
+        <p:txBody>
+          <a:bodyPr wrap="square" rtlCol="0">
+            <a:spAutoFit/>
+          </a:bodyPr>
+          <a:lstStyle/>
+          <a:p>
+            <a:r>
+              <a:rPr lang="en-US" sz="800" b="1" noProof="1"/>
+              <a:t>Some file operations should work both locally and on server.  </a:t>
+            </a:r>
+            <a:br>
+              <a:rPr lang="en-US" sz="800" b="1" noProof="1"/>
+            </a:br>
+            <a:endParaRPr lang="en-US" sz="800" b="1" noProof="1"/>
+          </a:p>
+          <a:p>
+            <a:pPr marL="171450" indent="-171450">
+              <a:buFont typeface="Courier New" panose="02070309020205020404" pitchFamily="49" charset="0"/>
+              <a:buChar char="o"/>
+            </a:pPr>
+            <a:r>
+              <a:rPr lang="en-US" sz="800" noProof="1">
+                <a:solidFill>
+                  <a:schemeClr val="accent1"/>
+                </a:solidFill>
+              </a:rPr>
+              <a:t>ssh_folder/ssh-folderlib.js </a:t>
+            </a:r>
+            <a:r>
+              <a:rPr lang="en-US" sz="800" noProof="1"/>
+              <a:t>is  javascript wrappers to bash scripts in “ssh_folder”.</a:t>
+            </a:r>
+            <a:br>
+              <a:rPr lang="en-US" sz="800" noProof="1"/>
+            </a:br>
+            <a:r>
+              <a:rPr lang="en-US" sz="800" noProof="1"/>
+              <a:t>Some functions are exclusive ssh, some are made to work both locally and over ssh</a:t>
+            </a:r>
+          </a:p>
+          <a:p>
+            <a:pPr marL="171450" indent="-171450">
+              <a:buFont typeface="Courier New" panose="02070309020205020404" pitchFamily="49" charset="0"/>
+              <a:buChar char="o"/>
+            </a:pPr>
+            <a:r>
+              <a:rPr lang="en-US" sz="800" noProof="1">
+                <a:solidFill>
+                  <a:schemeClr val="accent1"/>
+                </a:solidFill>
+              </a:rPr>
+              <a:t>fs_existsSync  </a:t>
+            </a:r>
+            <a:r>
+              <a:rPr lang="en-US" sz="800" noProof="1"/>
+              <a:t>-- works transparently as fs.existsSync both  on server and locally</a:t>
+            </a:r>
+            <a:br>
+              <a:rPr lang="en-US" sz="800" noProof="1"/>
+            </a:br>
+            <a:r>
+              <a:rPr lang="en-US" sz="800" noProof="1">
+                <a:solidFill>
+                  <a:schemeClr val="accent1"/>
+                </a:solidFill>
+              </a:rPr>
+              <a:t>fs.existsSync  </a:t>
+            </a:r>
+            <a:r>
+              <a:rPr lang="en-US" sz="800" noProof="1"/>
+              <a:t>-- works only locally (used for signal files, settings, Notes, etc that should not be on ssh server)</a:t>
+            </a:r>
+          </a:p>
+          <a:p>
+            <a:pPr marL="171450" indent="-171450">
+              <a:buFont typeface="Courier New" panose="02070309020205020404" pitchFamily="49" charset="0"/>
+              <a:buChar char="o"/>
+            </a:pPr>
+            <a:endParaRPr lang="en-US" sz="800" noProof="1"/>
           </a:p>
         </p:txBody>
       </p:sp>

</xml_diff>

<commit_message>
Update to nwjs 0.100.1
</commit_message>
<xml_diff>
--- a/docs/Tech-overview.pptx
+++ b/docs/Tech-overview.pptx
@@ -4166,6 +4166,269 @@
             <a:r>
               <a:rPr lang="en-US" sz="2400" b="1" noProof="1"/>
               <a:t>Pre-release</a:t>
+            </a:r>
+          </a:p>
+        </p:txBody>
+      </p:sp>
+      <p:sp>
+        <p:nvSpPr>
+          <p:cNvPr id="2" name="textruta 7">
+            <a:extLst>
+              <a:ext uri="{FF2B5EF4-FFF2-40B4-BE49-F238E27FC236}">
+                <a16:creationId xmlns:a16="http://schemas.microsoft.com/office/drawing/2014/main" id="{BA4EEBAF-B070-ABA0-6841-81950B660846}"/>
+              </a:ext>
+            </a:extLst>
+          </p:cNvPr>
+          <p:cNvSpPr txBox="1"/>
+          <p:nvPr/>
+        </p:nvSpPr>
+        <p:spPr>
+          <a:xfrm>
+            <a:off x="8057615" y="955246"/>
+            <a:ext cx="2816540" cy="461665"/>
+          </a:xfrm>
+          <a:prstGeom prst="rect">
+            <a:avLst/>
+          </a:prstGeom>
+          <a:noFill/>
+        </p:spPr>
+        <p:txBody>
+          <a:bodyPr wrap="none" rtlCol="0">
+            <a:spAutoFit/>
+          </a:bodyPr>
+          <a:lstStyle/>
+          <a:p>
+            <a:r>
+              <a:rPr lang="en-US" sz="2400" b="1" noProof="1"/>
+              <a:t>Change nwjs-version</a:t>
+            </a:r>
+          </a:p>
+        </p:txBody>
+      </p:sp>
+      <p:sp>
+        <p:nvSpPr>
+          <p:cNvPr id="3" name="textruta 6">
+            <a:extLst>
+              <a:ext uri="{FF2B5EF4-FFF2-40B4-BE49-F238E27FC236}">
+                <a16:creationId xmlns:a16="http://schemas.microsoft.com/office/drawing/2014/main" id="{DB43E805-6425-D6EA-8BA3-2E44D0EF7CBB}"/>
+              </a:ext>
+            </a:extLst>
+          </p:cNvPr>
+          <p:cNvSpPr txBox="1"/>
+          <p:nvPr/>
+        </p:nvSpPr>
+        <p:spPr>
+          <a:xfrm>
+            <a:off x="8067140" y="1545040"/>
+            <a:ext cx="3274288" cy="2800767"/>
+          </a:xfrm>
+          <a:prstGeom prst="rect">
+            <a:avLst/>
+          </a:prstGeom>
+          <a:noFill/>
+          <a:ln>
+            <a:solidFill>
+              <a:schemeClr val="accent1"/>
+            </a:solidFill>
+          </a:ln>
+        </p:spPr>
+        <p:txBody>
+          <a:bodyPr wrap="square" rtlCol="0">
+            <a:spAutoFit/>
+          </a:bodyPr>
+          <a:lstStyle/>
+          <a:p>
+            <a:pPr marL="228600" indent="-228600">
+              <a:buFont typeface="+mj-lt"/>
+              <a:buAutoNum type="arabicPeriod"/>
+            </a:pPr>
+            <a:r>
+              <a:rPr lang="en-US" sz="800" b="1" noProof="1"/>
+              <a:t>Download</a:t>
+            </a:r>
+            <a:r>
+              <a:rPr lang="en-US" sz="800" noProof="1"/>
+              <a:t> new nwjs-version to /Apps/nwjs.app</a:t>
+            </a:r>
+          </a:p>
+          <a:p>
+            <a:pPr marL="228600" indent="-228600">
+              <a:buFont typeface="+mj-lt"/>
+              <a:buAutoNum type="arabicPeriod"/>
+            </a:pPr>
+            <a:endParaRPr lang="en-US" sz="800" noProof="1"/>
+          </a:p>
+          <a:p>
+            <a:pPr marL="228600" indent="-228600">
+              <a:buFont typeface="+mj-lt"/>
+              <a:buAutoNum type="arabicPeriod"/>
+            </a:pPr>
+            <a:r>
+              <a:rPr lang="en-US" sz="800" b="1" noProof="1"/>
+              <a:t>Make runnable:</a:t>
+            </a:r>
+            <a:br>
+              <a:rPr lang="en-US" sz="800" b="1" noProof="1"/>
+            </a:br>
+            <a:r>
+              <a:rPr lang="en-US" sz="800" noProof="1"/>
+              <a:t>sudo xattr -r -d com.apple.quarantine /Applications/nwjs.app</a:t>
+            </a:r>
+          </a:p>
+          <a:p>
+            <a:pPr marL="228600" indent="-228600">
+              <a:buFont typeface="+mj-lt"/>
+              <a:buAutoNum type="arabicPeriod"/>
+            </a:pPr>
+            <a:endParaRPr lang="en-US" sz="800" noProof="1"/>
+          </a:p>
+          <a:p>
+            <a:pPr marL="228600" indent="-228600">
+              <a:buFont typeface="+mj-lt"/>
+              <a:buAutoNum type="arabicPeriod"/>
+            </a:pPr>
+            <a:r>
+              <a:rPr lang="en-US" sz="800" b="1" noProof="1"/>
+              <a:t>Update</a:t>
+            </a:r>
+            <a:r>
+              <a:rPr lang="en-US" sz="800" noProof="1"/>
+              <a:t> </a:t>
+            </a:r>
+            <a:r>
+              <a:rPr lang="en-US" sz="800" b="1" noProof="1"/>
+              <a:t>package.json </a:t>
+            </a:r>
+            <a:r>
+              <a:rPr lang="en-US" sz="800" noProof="1"/>
+              <a:t>to correct nwjs version</a:t>
+            </a:r>
+          </a:p>
+          <a:p>
+            <a:pPr marL="228600" indent="-228600">
+              <a:buFont typeface="+mj-lt"/>
+              <a:buAutoNum type="arabicPeriod"/>
+            </a:pPr>
+            <a:endParaRPr lang="en-US" sz="800" noProof="1"/>
+          </a:p>
+          <a:p>
+            <a:pPr marL="228600" indent="-228600">
+              <a:buFont typeface="+mj-lt"/>
+              <a:buAutoNum type="arabicPeriod"/>
+            </a:pPr>
+            <a:r>
+              <a:rPr lang="en-US" sz="800" b="1" noProof="1"/>
+              <a:t>F12 when running pragma-git, then</a:t>
+            </a:r>
+            <a:br>
+              <a:rPr lang="en-US" sz="800" noProof="1"/>
+            </a:br>
+            <a:r>
+              <a:rPr lang="en-US" sz="800" noProof="1"/>
+              <a:t>process.version  // gives node version (also Settings Info)</a:t>
+            </a:r>
+          </a:p>
+          <a:p>
+            <a:pPr marL="228600" indent="-228600">
+              <a:buFont typeface="+mj-lt"/>
+              <a:buAutoNum type="arabicPeriod"/>
+            </a:pPr>
+            <a:endParaRPr lang="en-US" sz="800" noProof="1"/>
+          </a:p>
+          <a:p>
+            <a:pPr marL="228600" indent="-228600">
+              <a:buFont typeface="+mj-lt"/>
+              <a:buAutoNum type="arabicPeriod"/>
+            </a:pPr>
+            <a:r>
+              <a:rPr lang="en-US" sz="800" b="1" noProof="1"/>
+              <a:t>Update NODE  to same version as prcess.version.  In bash :</a:t>
+            </a:r>
+            <a:br>
+              <a:rPr lang="en-US" sz="800" noProof="1"/>
+            </a:br>
+            <a:r>
+              <a:rPr lang="en-US" sz="800" noProof="1"/>
+              <a:t>cd /Users/jan/Documents/Projects/Pragma-git/pragma-git/</a:t>
+            </a:r>
+            <a:br>
+              <a:rPr lang="en-US" sz="800" noProof="1"/>
+            </a:br>
+            <a:r>
+              <a:rPr lang="en-US" sz="800" noProof="1"/>
+              <a:t>volta install node@VERSION  # for instance: “node@21.1.0”</a:t>
+            </a:r>
+          </a:p>
+          <a:p>
+            <a:pPr marL="228600" indent="-228600">
+              <a:buFont typeface="+mj-lt"/>
+              <a:buAutoNum type="arabicPeriod"/>
+            </a:pPr>
+            <a:endParaRPr lang="en-US" sz="800" noProof="1"/>
+          </a:p>
+          <a:p>
+            <a:pPr marL="228600" indent="-228600">
+              <a:buFont typeface="+mj-lt"/>
+              <a:buAutoNum type="arabicPeriod"/>
+            </a:pPr>
+            <a:r>
+              <a:rPr lang="en-US" sz="800" b="1" noProof="1"/>
+              <a:t>Update npm versions in bash :</a:t>
+            </a:r>
+            <a:br>
+              <a:rPr lang="en-US" sz="800" noProof="1"/>
+            </a:br>
+            <a:r>
+              <a:rPr lang="en-US" sz="800" noProof="1"/>
+              <a:t>cd /Users/jan/Documents/Projects/Pragma-git/pragma-git/</a:t>
+            </a:r>
+            <a:br>
+              <a:rPr lang="en-US" sz="800" noProof="1"/>
+            </a:br>
+            <a:r>
+              <a:rPr lang="en-US" sz="800" noProof="1"/>
+              <a:t>npm update</a:t>
+            </a:r>
+          </a:p>
+          <a:p>
+            <a:pPr marL="228600" indent="-228600">
+              <a:buFont typeface="+mj-lt"/>
+              <a:buAutoNum type="arabicPeriod"/>
+            </a:pPr>
+            <a:endParaRPr lang="en-US" sz="800" noProof="1"/>
+          </a:p>
+          <a:p>
+            <a:pPr marL="228600" indent="-228600">
+              <a:buFont typeface="+mj-lt"/>
+              <a:buAutoNum type="arabicPeriod"/>
+            </a:pPr>
+            <a:r>
+              <a:rPr lang="en-US" sz="800" b="1" noProof="1"/>
+              <a:t>Check what package versions are not updated .</a:t>
+            </a:r>
+            <a:r>
+              <a:rPr lang="en-US" sz="800" noProof="1"/>
+              <a:t> </a:t>
+            </a:r>
+            <a:r>
+              <a:rPr lang="en-US" sz="800" b="1" noProof="1"/>
+              <a:t>In bash:</a:t>
+            </a:r>
+            <a:br>
+              <a:rPr lang="en-US" sz="800" b="1" noProof="1"/>
+            </a:br>
+            <a:r>
+              <a:rPr lang="en-US" sz="800" noProof="1"/>
+              <a:t>npm outdated</a:t>
+            </a:r>
+          </a:p>
+          <a:p>
+            <a:endParaRPr lang="en-US" sz="800" noProof="1"/>
+          </a:p>
+          <a:p>
+            <a:r>
+              <a:rPr lang="en-US" sz="800" b="1" noProof="1"/>
+              <a:t>... keep working ...</a:t>
             </a:r>
           </a:p>
         </p:txBody>

</xml_diff>

<commit_message>
Document git over ssh (ssh folders)
</commit_message>
<xml_diff>
--- a/docs/Tech-overview.pptx
+++ b/docs/Tech-overview.pptx
@@ -264,7 +264,7 @@
           <a:p>
             <a:fld id="{CA855E1B-8830-B64E-B102-DB2BBD0D9567}" type="datetimeFigureOut">
               <a:rPr lang="sv-SE" smtClean="0"/>
-              <a:t>2025-06-04</a:t>
+              <a:t>2025-06-27</a:t>
             </a:fld>
             <a:endParaRPr lang="sv-SE"/>
           </a:p>
@@ -434,7 +434,7 @@
           <a:p>
             <a:fld id="{CA855E1B-8830-B64E-B102-DB2BBD0D9567}" type="datetimeFigureOut">
               <a:rPr lang="sv-SE" smtClean="0"/>
-              <a:t>2025-06-04</a:t>
+              <a:t>2025-06-27</a:t>
             </a:fld>
             <a:endParaRPr lang="sv-SE"/>
           </a:p>
@@ -614,7 +614,7 @@
           <a:p>
             <a:fld id="{CA855E1B-8830-B64E-B102-DB2BBD0D9567}" type="datetimeFigureOut">
               <a:rPr lang="sv-SE" smtClean="0"/>
-              <a:t>2025-06-04</a:t>
+              <a:t>2025-06-27</a:t>
             </a:fld>
             <a:endParaRPr lang="sv-SE"/>
           </a:p>
@@ -784,7 +784,7 @@
           <a:p>
             <a:fld id="{CA855E1B-8830-B64E-B102-DB2BBD0D9567}" type="datetimeFigureOut">
               <a:rPr lang="sv-SE" smtClean="0"/>
-              <a:t>2025-06-04</a:t>
+              <a:t>2025-06-27</a:t>
             </a:fld>
             <a:endParaRPr lang="sv-SE"/>
           </a:p>
@@ -1028,7 +1028,7 @@
           <a:p>
             <a:fld id="{CA855E1B-8830-B64E-B102-DB2BBD0D9567}" type="datetimeFigureOut">
               <a:rPr lang="sv-SE" smtClean="0"/>
-              <a:t>2025-06-04</a:t>
+              <a:t>2025-06-27</a:t>
             </a:fld>
             <a:endParaRPr lang="sv-SE"/>
           </a:p>
@@ -1260,7 +1260,7 @@
           <a:p>
             <a:fld id="{CA855E1B-8830-B64E-B102-DB2BBD0D9567}" type="datetimeFigureOut">
               <a:rPr lang="sv-SE" smtClean="0"/>
-              <a:t>2025-06-04</a:t>
+              <a:t>2025-06-27</a:t>
             </a:fld>
             <a:endParaRPr lang="sv-SE"/>
           </a:p>
@@ -1627,7 +1627,7 @@
           <a:p>
             <a:fld id="{CA855E1B-8830-B64E-B102-DB2BBD0D9567}" type="datetimeFigureOut">
               <a:rPr lang="sv-SE" smtClean="0"/>
-              <a:t>2025-06-04</a:t>
+              <a:t>2025-06-27</a:t>
             </a:fld>
             <a:endParaRPr lang="sv-SE"/>
           </a:p>
@@ -1745,7 +1745,7 @@
           <a:p>
             <a:fld id="{CA855E1B-8830-B64E-B102-DB2BBD0D9567}" type="datetimeFigureOut">
               <a:rPr lang="sv-SE" smtClean="0"/>
-              <a:t>2025-06-04</a:t>
+              <a:t>2025-06-27</a:t>
             </a:fld>
             <a:endParaRPr lang="sv-SE"/>
           </a:p>
@@ -1840,7 +1840,7 @@
           <a:p>
             <a:fld id="{CA855E1B-8830-B64E-B102-DB2BBD0D9567}" type="datetimeFigureOut">
               <a:rPr lang="sv-SE" smtClean="0"/>
-              <a:t>2025-06-04</a:t>
+              <a:t>2025-06-27</a:t>
             </a:fld>
             <a:endParaRPr lang="sv-SE"/>
           </a:p>
@@ -2117,7 +2117,7 @@
           <a:p>
             <a:fld id="{CA855E1B-8830-B64E-B102-DB2BBD0D9567}" type="datetimeFigureOut">
               <a:rPr lang="sv-SE" smtClean="0"/>
-              <a:t>2025-06-04</a:t>
+              <a:t>2025-06-27</a:t>
             </a:fld>
             <a:endParaRPr lang="sv-SE"/>
           </a:p>
@@ -2374,7 +2374,7 @@
           <a:p>
             <a:fld id="{CA855E1B-8830-B64E-B102-DB2BBD0D9567}" type="datetimeFigureOut">
               <a:rPr lang="sv-SE" smtClean="0"/>
-              <a:t>2025-06-04</a:t>
+              <a:t>2025-06-27</a:t>
             </a:fld>
             <a:endParaRPr lang="sv-SE"/>
           </a:p>
@@ -2587,7 +2587,7 @@
           <a:p>
             <a:fld id="{CA855E1B-8830-B64E-B102-DB2BBD0D9567}" type="datetimeFigureOut">
               <a:rPr lang="sv-SE" smtClean="0"/>
-              <a:t>2025-06-04</a:t>
+              <a:t>2025-06-27</a:t>
             </a:fld>
             <a:endParaRPr lang="sv-SE"/>
           </a:p>
@@ -14201,7 +14201,7 @@
         <p:spPr>
           <a:xfrm>
             <a:off x="451706" y="3328078"/>
-            <a:ext cx="11226129" cy="5950956"/>
+            <a:ext cx="11226129" cy="6066014"/>
           </a:xfrm>
           <a:prstGeom prst="rect">
             <a:avLst/>
@@ -14257,8 +14257,8 @@
         </p:nvSpPr>
         <p:spPr>
           <a:xfrm>
-            <a:off x="6096044" y="3562275"/>
-            <a:ext cx="5154004" cy="4462272"/>
+            <a:off x="5979753" y="3784842"/>
+            <a:ext cx="5608633" cy="4868654"/>
           </a:xfrm>
           <a:prstGeom prst="rect">
             <a:avLst/>
@@ -14266,7 +14266,11 @@
           <a:solidFill>
             <a:schemeClr val="bg1"/>
           </a:solidFill>
-          <a:ln w="0"/>
+          <a:ln w="12700">
+            <a:solidFill>
+              <a:schemeClr val="accent1"/>
+            </a:solidFill>
+          </a:ln>
         </p:spPr>
         <p:style>
           <a:lnRef idx="2">
@@ -14353,7 +14357,7 @@
             <a:avLst/>
           </a:prstGeom>
           <a:noFill/>
-          <a:ln>
+          <a:ln w="12700">
             <a:solidFill>
               <a:schemeClr val="accent1"/>
             </a:solidFill>
@@ -14499,7 +14503,7 @@
         </p:nvSpPr>
         <p:spPr>
           <a:xfrm>
-            <a:off x="599550" y="3562275"/>
+            <a:off x="559609" y="3786855"/>
             <a:ext cx="5019594" cy="5509200"/>
           </a:xfrm>
           <a:prstGeom prst="rect">
@@ -14508,7 +14512,7 @@
           <a:solidFill>
             <a:schemeClr val="bg1"/>
           </a:solidFill>
-          <a:ln>
+          <a:ln w="12700">
             <a:solidFill>
               <a:schemeClr val="accent1"/>
             </a:solidFill>
@@ -15046,7 +15050,7 @@
         </p:nvSpPr>
         <p:spPr>
           <a:xfrm>
-            <a:off x="6729172" y="3670019"/>
+            <a:off x="6818173" y="3832476"/>
             <a:ext cx="572366" cy="246221"/>
           </a:xfrm>
           <a:prstGeom prst="rect">
@@ -15082,7 +15086,7 @@
         </p:nvSpPr>
         <p:spPr>
           <a:xfrm>
-            <a:off x="9281254" y="3639459"/>
+            <a:off x="9370255" y="3801916"/>
             <a:ext cx="820793" cy="246221"/>
           </a:xfrm>
           <a:prstGeom prst="rect">
@@ -16291,48 +16295,6 @@
       </p:sp>
       <p:sp>
         <p:nvSpPr>
-          <p:cNvPr id="124" name="TextBox 123">
-            <a:extLst>
-              <a:ext uri="{FF2B5EF4-FFF2-40B4-BE49-F238E27FC236}">
-                <a16:creationId xmlns:a16="http://schemas.microsoft.com/office/drawing/2014/main" id="{A3A75491-E066-021D-9B1B-CCADDB40C015}"/>
-              </a:ext>
-            </a:extLst>
-          </p:cNvPr>
-          <p:cNvSpPr txBox="1"/>
-          <p:nvPr/>
-        </p:nvSpPr>
-        <p:spPr>
-          <a:xfrm>
-            <a:off x="6193794" y="8117958"/>
-            <a:ext cx="5484041" cy="400110"/>
-          </a:xfrm>
-          <a:prstGeom prst="rect">
-            <a:avLst/>
-          </a:prstGeom>
-          <a:noFill/>
-        </p:spPr>
-        <p:txBody>
-          <a:bodyPr wrap="square">
-            <a:spAutoFit/>
-          </a:bodyPr>
-          <a:lstStyle/>
-          <a:p>
-            <a:r>
-              <a:rPr lang="en-US" sz="1000" noProof="1"/>
-              <a:t>*)  NOTE, git difftool waits until pragma-merge is closed. That’s why I start a delayed local</a:t>
-            </a:r>
-          </a:p>
-          <a:p>
-            <a:r>
-              <a:rPr lang="en-US" sz="1000" noProof="1"/>
-              <a:t> pick-up of files -- to give server difftool time to generate BASE, … .</a:t>
-            </a:r>
-            <a:endParaRPr lang="en-US" sz="1000" dirty="0"/>
-          </a:p>
-        </p:txBody>
-      </p:sp>
-      <p:sp>
-        <p:nvSpPr>
           <p:cNvPr id="125" name="TextBox 124">
             <a:extLst>
               <a:ext uri="{FF2B5EF4-FFF2-40B4-BE49-F238E27FC236}">
@@ -16549,7 +16511,7 @@
             <a:avLst/>
           </a:prstGeom>
           <a:noFill/>
-          <a:ln>
+          <a:ln w="12700">
             <a:solidFill>
               <a:schemeClr val="accent1"/>
             </a:solidFill>
@@ -16634,6 +16596,156 @@
               <a:buChar char="o"/>
             </a:pPr>
             <a:endParaRPr lang="en-US" sz="800" noProof="1"/>
+          </a:p>
+        </p:txBody>
+      </p:sp>
+      <p:sp>
+        <p:nvSpPr>
+          <p:cNvPr id="9" name="TextBox 8">
+            <a:extLst>
+              <a:ext uri="{FF2B5EF4-FFF2-40B4-BE49-F238E27FC236}">
+                <a16:creationId xmlns:a16="http://schemas.microsoft.com/office/drawing/2014/main" id="{ABB4C26E-1F75-21FF-1C5B-FA2AA1E1E0E0}"/>
+              </a:ext>
+            </a:extLst>
+          </p:cNvPr>
+          <p:cNvSpPr txBox="1"/>
+          <p:nvPr/>
+        </p:nvSpPr>
+        <p:spPr>
+          <a:xfrm>
+            <a:off x="513990" y="3407195"/>
+            <a:ext cx="5019595" cy="307777"/>
+          </a:xfrm>
+          <a:prstGeom prst="rect">
+            <a:avLst/>
+          </a:prstGeom>
+          <a:noFill/>
+        </p:spPr>
+        <p:txBody>
+          <a:bodyPr wrap="square">
+            <a:spAutoFit/>
+          </a:bodyPr>
+          <a:lstStyle/>
+          <a:p>
+            <a:r>
+              <a:rPr lang="en-US" sz="1000" b="1" noProof="1"/>
+              <a:t>BELOW IS DOCUMENTED IN  </a:t>
+            </a:r>
+            <a:r>
+              <a:rPr lang="en-US" sz="1400" b="1" noProof="1">
+                <a:hlinkClick r:id="rId2"/>
+              </a:rPr>
+              <a:t>SSH-folder-documentation.xlsx</a:t>
+            </a:r>
+            <a:endParaRPr lang="en-US" sz="1400" b="1" dirty="0"/>
+          </a:p>
+        </p:txBody>
+      </p:sp>
+      <p:sp>
+        <p:nvSpPr>
+          <p:cNvPr id="11" name="TextBox 10">
+            <a:extLst>
+              <a:ext uri="{FF2B5EF4-FFF2-40B4-BE49-F238E27FC236}">
+                <a16:creationId xmlns:a16="http://schemas.microsoft.com/office/drawing/2014/main" id="{6AD517F4-28AB-E486-0DB1-C8B56C3E504D}"/>
+              </a:ext>
+            </a:extLst>
+          </p:cNvPr>
+          <p:cNvSpPr txBox="1"/>
+          <p:nvPr/>
+        </p:nvSpPr>
+        <p:spPr>
+          <a:xfrm>
+            <a:off x="5996356" y="8720843"/>
+            <a:ext cx="5592030" cy="553998"/>
+          </a:xfrm>
+          <a:prstGeom prst="rect">
+            <a:avLst/>
+          </a:prstGeom>
+          <a:solidFill>
+            <a:schemeClr val="bg1"/>
+          </a:solidFill>
+          <a:ln>
+            <a:solidFill>
+              <a:schemeClr val="accent1"/>
+            </a:solidFill>
+          </a:ln>
+        </p:spPr>
+        <p:txBody>
+          <a:bodyPr wrap="square">
+            <a:spAutoFit/>
+          </a:bodyPr>
+          <a:lstStyle/>
+          <a:p>
+            <a:r>
+              <a:rPr lang="en-US" sz="1000" b="1" noProof="1"/>
+              <a:t>Reading and Writing files </a:t>
+            </a:r>
+            <a:r>
+              <a:rPr lang="en-US" sz="1000" noProof="1"/>
+              <a:t>relative the server’s repo base, is done with additional scripts:</a:t>
+            </a:r>
+          </a:p>
+          <a:p>
+            <a:pPr marL="171450" indent="-171450">
+              <a:buFont typeface="Arial" panose="020B0604020202020204" pitchFamily="34" charset="0"/>
+              <a:buChar char="•"/>
+            </a:pPr>
+            <a:r>
+              <a:rPr lang="en-US" sz="1000" noProof="1"/>
+              <a:t>ssh-get  --  Used for edit-link in changed list, and for .gitignore tool</a:t>
+            </a:r>
+          </a:p>
+          <a:p>
+            <a:pPr marL="171450" indent="-171450">
+              <a:buFont typeface="Arial" panose="020B0604020202020204" pitchFamily="34" charset="0"/>
+              <a:buChar char="•"/>
+            </a:pPr>
+            <a:r>
+              <a:rPr lang="en-US" sz="1000" noProof="1"/>
+              <a:t>ssh-put  --  Used to update server file after a file is modified in pragma-merge. Also for .gitignore tool</a:t>
+            </a:r>
+          </a:p>
+        </p:txBody>
+      </p:sp>
+      <p:sp>
+        <p:nvSpPr>
+          <p:cNvPr id="124" name="TextBox 123">
+            <a:extLst>
+              <a:ext uri="{FF2B5EF4-FFF2-40B4-BE49-F238E27FC236}">
+                <a16:creationId xmlns:a16="http://schemas.microsoft.com/office/drawing/2014/main" id="{A3A75491-E066-021D-9B1B-CCADDB40C015}"/>
+              </a:ext>
+            </a:extLst>
+          </p:cNvPr>
+          <p:cNvSpPr txBox="1"/>
+          <p:nvPr/>
+        </p:nvSpPr>
+        <p:spPr>
+          <a:xfrm>
+            <a:off x="6035314" y="8179239"/>
+            <a:ext cx="5484041" cy="400110"/>
+          </a:xfrm>
+          <a:prstGeom prst="rect">
+            <a:avLst/>
+          </a:prstGeom>
+          <a:noFill/>
+        </p:spPr>
+        <p:txBody>
+          <a:bodyPr wrap="square">
+            <a:spAutoFit/>
+          </a:bodyPr>
+          <a:lstStyle/>
+          <a:p>
+            <a:r>
+              <a:rPr lang="en-US" sz="1000" noProof="1"/>
+              <a:t>*)  NOTE, git difftool waits until pragma-merge is closed. That’s why I start a delayed local</a:t>
+            </a:r>
+          </a:p>
+          <a:p>
+            <a:r>
+              <a:rPr lang="en-US" sz="1000" noProof="1"/>
+              <a:t> pick-up of files -- to give server difftool time to generate BASE, … .</a:t>
+            </a:r>
+            <a:endParaRPr lang="en-US" sz="1000" dirty="0"/>
           </a:p>
         </p:txBody>
       </p:sp>

</xml_diff>

<commit_message>
Return local config file when no input parameter in configFilePath() -- inhibits ssh folder
</commit_message>
<xml_diff>
--- a/docs/Tech-overview.pptx
+++ b/docs/Tech-overview.pptx
@@ -264,7 +264,7 @@
           <a:p>
             <a:fld id="{CA855E1B-8830-B64E-B102-DB2BBD0D9567}" type="datetimeFigureOut">
               <a:rPr lang="sv-SE" smtClean="0"/>
-              <a:t>2025-06-27</a:t>
+              <a:t>2025-09-10</a:t>
             </a:fld>
             <a:endParaRPr lang="sv-SE"/>
           </a:p>
@@ -434,7 +434,7 @@
           <a:p>
             <a:fld id="{CA855E1B-8830-B64E-B102-DB2BBD0D9567}" type="datetimeFigureOut">
               <a:rPr lang="sv-SE" smtClean="0"/>
-              <a:t>2025-06-27</a:t>
+              <a:t>2025-09-10</a:t>
             </a:fld>
             <a:endParaRPr lang="sv-SE"/>
           </a:p>
@@ -614,7 +614,7 @@
           <a:p>
             <a:fld id="{CA855E1B-8830-B64E-B102-DB2BBD0D9567}" type="datetimeFigureOut">
               <a:rPr lang="sv-SE" smtClean="0"/>
-              <a:t>2025-06-27</a:t>
+              <a:t>2025-09-10</a:t>
             </a:fld>
             <a:endParaRPr lang="sv-SE"/>
           </a:p>
@@ -784,7 +784,7 @@
           <a:p>
             <a:fld id="{CA855E1B-8830-B64E-B102-DB2BBD0D9567}" type="datetimeFigureOut">
               <a:rPr lang="sv-SE" smtClean="0"/>
-              <a:t>2025-06-27</a:t>
+              <a:t>2025-09-10</a:t>
             </a:fld>
             <a:endParaRPr lang="sv-SE"/>
           </a:p>
@@ -1028,7 +1028,7 @@
           <a:p>
             <a:fld id="{CA855E1B-8830-B64E-B102-DB2BBD0D9567}" type="datetimeFigureOut">
               <a:rPr lang="sv-SE" smtClean="0"/>
-              <a:t>2025-06-27</a:t>
+              <a:t>2025-09-10</a:t>
             </a:fld>
             <a:endParaRPr lang="sv-SE"/>
           </a:p>
@@ -1260,7 +1260,7 @@
           <a:p>
             <a:fld id="{CA855E1B-8830-B64E-B102-DB2BBD0D9567}" type="datetimeFigureOut">
               <a:rPr lang="sv-SE" smtClean="0"/>
-              <a:t>2025-06-27</a:t>
+              <a:t>2025-09-10</a:t>
             </a:fld>
             <a:endParaRPr lang="sv-SE"/>
           </a:p>
@@ -1627,7 +1627,7 @@
           <a:p>
             <a:fld id="{CA855E1B-8830-B64E-B102-DB2BBD0D9567}" type="datetimeFigureOut">
               <a:rPr lang="sv-SE" smtClean="0"/>
-              <a:t>2025-06-27</a:t>
+              <a:t>2025-09-10</a:t>
             </a:fld>
             <a:endParaRPr lang="sv-SE"/>
           </a:p>
@@ -1745,7 +1745,7 @@
           <a:p>
             <a:fld id="{CA855E1B-8830-B64E-B102-DB2BBD0D9567}" type="datetimeFigureOut">
               <a:rPr lang="sv-SE" smtClean="0"/>
-              <a:t>2025-06-27</a:t>
+              <a:t>2025-09-10</a:t>
             </a:fld>
             <a:endParaRPr lang="sv-SE"/>
           </a:p>
@@ -1840,7 +1840,7 @@
           <a:p>
             <a:fld id="{CA855E1B-8830-B64E-B102-DB2BBD0D9567}" type="datetimeFigureOut">
               <a:rPr lang="sv-SE" smtClean="0"/>
-              <a:t>2025-06-27</a:t>
+              <a:t>2025-09-10</a:t>
             </a:fld>
             <a:endParaRPr lang="sv-SE"/>
           </a:p>
@@ -2117,7 +2117,7 @@
           <a:p>
             <a:fld id="{CA855E1B-8830-B64E-B102-DB2BBD0D9567}" type="datetimeFigureOut">
               <a:rPr lang="sv-SE" smtClean="0"/>
-              <a:t>2025-06-27</a:t>
+              <a:t>2025-09-10</a:t>
             </a:fld>
             <a:endParaRPr lang="sv-SE"/>
           </a:p>
@@ -2374,7 +2374,7 @@
           <a:p>
             <a:fld id="{CA855E1B-8830-B64E-B102-DB2BBD0D9567}" type="datetimeFigureOut">
               <a:rPr lang="sv-SE" smtClean="0"/>
-              <a:t>2025-06-27</a:t>
+              <a:t>2025-09-10</a:t>
             </a:fld>
             <a:endParaRPr lang="sv-SE"/>
           </a:p>
@@ -2587,7 +2587,7 @@
           <a:p>
             <a:fld id="{CA855E1B-8830-B64E-B102-DB2BBD0D9567}" type="datetimeFigureOut">
               <a:rPr lang="sv-SE" smtClean="0"/>
-              <a:t>2025-06-27</a:t>
+              <a:t>2025-09-10</a:t>
             </a:fld>
             <a:endParaRPr lang="sv-SE"/>
           </a:p>

</xml_diff>

<commit_message>
ssh-git-client -- documentation, and fix minor askpass bug
</commit_message>
<xml_diff>
--- a/docs/Tech-overview.pptx
+++ b/docs/Tech-overview.pptx
@@ -18458,7 +18458,7 @@
         <p:spPr>
           <a:xfrm>
             <a:off x="606743" y="1976909"/>
-            <a:ext cx="5019594" cy="5509200"/>
+            <a:ext cx="5019594" cy="4524315"/>
           </a:xfrm>
           <a:prstGeom prst="rect">
             <a:avLst/>
@@ -18615,7 +18615,7 @@
             </a:br>
             <a:r>
               <a:rPr lang="en-US" sz="800" noProof="1"/>
-              <a:t>(FILE_LIST_ON_SSH  = /tmp/test.txt)</a:t>
+              <a:t>(FILE_LIST_ON_SSH  = /tmp/git_diff_file_list.txt)</a:t>
             </a:r>
             <a:br>
               <a:rPr lang="en-US" sz="800" b="1" noProof="1"/>
@@ -18633,12 +18633,9 @@
                   <a:schemeClr val="accent1"/>
                 </a:solidFill>
               </a:rPr>
-              <a:t>CLIENT : ssh-git-client (when difftool or mergetool) </a:t>
-            </a:r>
-            <a:r>
-              <a:rPr lang="en-US" sz="800" noProof="1"/>
-              <a:t>starts new shell</a:t>
-            </a:r>
+              <a:t>CLIENT : ssh-git-client (when difftool or mergetool)</a:t>
+            </a:r>
+            <a:endParaRPr lang="en-US" sz="800" noProof="1"/>
           </a:p>
           <a:p>
             <a:pPr marL="324000" lvl="1" indent="-171450">
@@ -18647,103 +18644,14 @@
             </a:pPr>
             <a:r>
               <a:rPr lang="en-US" sz="800" noProof="1"/>
-              <a:t>If difftool or mergetool command, </a:t>
+              <a:t>Check if $FILE_LIST_ON_SSH  exists</a:t>
             </a:r>
             <a:br>
               <a:rPr lang="en-US" sz="800" noProof="1"/>
             </a:br>
             <a:r>
               <a:rPr lang="en-US" sz="800" noProof="1"/>
-              <a:t>start “delayed-start-pragma-merge” in new shell</a:t>
-            </a:r>
-          </a:p>
-          <a:p>
-            <a:pPr marL="324000" lvl="1" indent="-171450">
-              <a:buFont typeface="Arial" panose="020B0604020202020204" pitchFamily="34" charset="0"/>
-              <a:buChar char="•"/>
-            </a:pPr>
-            <a:r>
-              <a:rPr lang="en-US" sz="800" noProof="1"/>
-              <a:t>Run the git diff/merge command on server</a:t>
-            </a:r>
-            <a:br>
-              <a:rPr lang="en-US" sz="800" noProof="1"/>
-            </a:br>
-            <a:endParaRPr lang="en-US" sz="800" noProof="1">
-              <a:solidFill>
-                <a:schemeClr val="accent1"/>
-              </a:solidFill>
-            </a:endParaRPr>
-          </a:p>
-          <a:p>
-            <a:pPr marL="171450" indent="-171450">
-              <a:buFont typeface="Courier New" panose="02070309020205020404" pitchFamily="49" charset="0"/>
-              <a:buChar char="o"/>
-            </a:pPr>
-            <a:r>
-              <a:rPr lang="en-US" sz="800" noProof="1">
-                <a:solidFill>
-                  <a:schemeClr val="accent1"/>
-                </a:solidFill>
-              </a:rPr>
-              <a:t>-&gt; CLIENT : delayed-start-pragma-merge</a:t>
-            </a:r>
-            <a:endParaRPr lang="en-US" sz="800" noProof="1"/>
-          </a:p>
-          <a:p>
-            <a:pPr marL="324000" lvl="1" indent="-171450">
-              <a:buFont typeface="Arial" panose="020B0604020202020204" pitchFamily="34" charset="0"/>
-              <a:buChar char="•"/>
-            </a:pPr>
-            <a:r>
-              <a:rPr lang="en-US" sz="800" noProof="1"/>
-              <a:t>Waits a few second for ssh-git-client to run on server</a:t>
-            </a:r>
-            <a:br>
-              <a:rPr lang="en-US" sz="800" noProof="1"/>
-            </a:br>
-            <a:r>
-              <a:rPr lang="en-US" sz="800" noProof="1"/>
-              <a:t>TODO: instead, check if $FILE_LIST_ON_SSH has been created</a:t>
-            </a:r>
-          </a:p>
-          <a:p>
-            <a:pPr marL="324000" lvl="1" indent="-171450">
-              <a:buFont typeface="Arial" panose="020B0604020202020204" pitchFamily="34" charset="0"/>
-              <a:buChar char="•"/>
-            </a:pPr>
-            <a:r>
-              <a:rPr lang="en-US" sz="800" noProof="1"/>
-              <a:t>Start ssh-get-merge-files, to pick up files from server</a:t>
-            </a:r>
-          </a:p>
-          <a:p>
-            <a:pPr marL="171450" indent="-171450">
-              <a:buFont typeface="Courier New" panose="02070309020205020404" pitchFamily="49" charset="0"/>
-              <a:buChar char="o"/>
-            </a:pPr>
-            <a:endParaRPr lang="en-US" sz="800" noProof="1">
-              <a:solidFill>
-                <a:schemeClr val="accent1"/>
-              </a:solidFill>
-            </a:endParaRPr>
-          </a:p>
-          <a:p>
-            <a:pPr marL="171450" indent="-171450">
-              <a:buFont typeface="Courier New" panose="02070309020205020404" pitchFamily="49" charset="0"/>
-              <a:buChar char="o"/>
-            </a:pPr>
-            <a:r>
-              <a:rPr lang="en-US" sz="800" noProof="1">
-                <a:solidFill>
-                  <a:schemeClr val="accent1"/>
-                </a:solidFill>
-              </a:rPr>
-              <a:t>-&gt; CLIENT; ssh-get-merge-files – </a:t>
-            </a:r>
-            <a:r>
-              <a:rPr lang="en-US" sz="800" noProof="1"/>
-              <a:t>picks up server files to client</a:t>
+              <a:t>If so: Picks up server files to client</a:t>
             </a:r>
           </a:p>
           <a:p>
@@ -19169,46 +19077,6 @@
       </p:sp>
       <p:sp>
         <p:nvSpPr>
-          <p:cNvPr id="28" name="TextBox 27">
-            <a:extLst>
-              <a:ext uri="{FF2B5EF4-FFF2-40B4-BE49-F238E27FC236}">
-                <a16:creationId xmlns:a16="http://schemas.microsoft.com/office/drawing/2014/main" id="{CC1CC32D-4682-DDFA-08D8-F2BCB69E4AC2}"/>
-              </a:ext>
-            </a:extLst>
-          </p:cNvPr>
-          <p:cNvSpPr txBox="1"/>
-          <p:nvPr/>
-        </p:nvSpPr>
-        <p:spPr>
-          <a:xfrm>
-            <a:off x="6497400" y="2800096"/>
-            <a:ext cx="1933528" cy="246221"/>
-          </a:xfrm>
-          <a:prstGeom prst="rect">
-            <a:avLst/>
-          </a:prstGeom>
-          <a:noFill/>
-        </p:spPr>
-        <p:txBody>
-          <a:bodyPr wrap="square">
-            <a:spAutoFit/>
-          </a:bodyPr>
-          <a:lstStyle/>
-          <a:p>
-            <a:r>
-              <a:rPr lang="en-US" sz="1000" noProof="1">
-                <a:solidFill>
-                  <a:schemeClr val="accent1"/>
-                </a:solidFill>
-              </a:rPr>
-              <a:t>delayed-start-pragma-merge</a:t>
-            </a:r>
-            <a:endParaRPr lang="en-US" sz="1000" dirty="0"/>
-          </a:p>
-        </p:txBody>
-      </p:sp>
-      <p:sp>
-        <p:nvSpPr>
           <p:cNvPr id="29" name="TextBox 28">
             <a:extLst>
               <a:ext uri="{FF2B5EF4-FFF2-40B4-BE49-F238E27FC236}">
@@ -19301,7 +19169,7 @@
         </p:nvSpPr>
         <p:spPr>
           <a:xfrm>
-            <a:off x="9110163" y="2668966"/>
+            <a:off x="9110163" y="2857506"/>
             <a:ext cx="1348913" cy="400110"/>
           </a:xfrm>
           <a:prstGeom prst="rect">
@@ -19363,12 +19231,90 @@
           </a:p>
         </p:txBody>
       </p:sp>
+      <p:sp>
+        <p:nvSpPr>
+          <p:cNvPr id="46" name="TextBox 45">
+            <a:extLst>
+              <a:ext uri="{FF2B5EF4-FFF2-40B4-BE49-F238E27FC236}">
+                <a16:creationId xmlns:a16="http://schemas.microsoft.com/office/drawing/2014/main" id="{F19CDB1A-EBE4-CE30-3404-1F0553AA9FF5}"/>
+              </a:ext>
+            </a:extLst>
+          </p:cNvPr>
+          <p:cNvSpPr txBox="1"/>
+          <p:nvPr/>
+        </p:nvSpPr>
+        <p:spPr>
+          <a:xfrm>
+            <a:off x="9186409" y="3383968"/>
+            <a:ext cx="2317325" cy="246221"/>
+          </a:xfrm>
+          <a:prstGeom prst="rect">
+            <a:avLst/>
+          </a:prstGeom>
+          <a:noFill/>
+        </p:spPr>
+        <p:txBody>
+          <a:bodyPr wrap="square">
+            <a:spAutoFit/>
+          </a:bodyPr>
+          <a:lstStyle/>
+          <a:p>
+            <a:r>
+              <a:rPr lang="en-US" sz="1000" noProof="1"/>
+              <a:t>$TMP/pragma-merge-running-ssh</a:t>
+            </a:r>
+            <a:endParaRPr lang="en-US" sz="1000" dirty="0"/>
+          </a:p>
+        </p:txBody>
+      </p:sp>
+      <p:sp>
+        <p:nvSpPr>
+          <p:cNvPr id="47" name="TextBox 46">
+            <a:extLst>
+              <a:ext uri="{FF2B5EF4-FFF2-40B4-BE49-F238E27FC236}">
+                <a16:creationId xmlns:a16="http://schemas.microsoft.com/office/drawing/2014/main" id="{8646281E-85BC-5DF3-3988-A0AA51D3C13B}"/>
+              </a:ext>
+            </a:extLst>
+          </p:cNvPr>
+          <p:cNvSpPr txBox="1"/>
+          <p:nvPr/>
+        </p:nvSpPr>
+        <p:spPr>
+          <a:xfrm>
+            <a:off x="9186409" y="3598056"/>
+            <a:ext cx="2317325" cy="400110"/>
+          </a:xfrm>
+          <a:prstGeom prst="rect">
+            <a:avLst/>
+          </a:prstGeom>
+          <a:noFill/>
+        </p:spPr>
+        <p:txBody>
+          <a:bodyPr wrap="square">
+            <a:spAutoFit/>
+          </a:bodyPr>
+          <a:lstStyle/>
+          <a:p>
+            <a:r>
+              <a:rPr lang="en-US" sz="1000" noProof="1"/>
+              <a:t>$FILE_LIST_ON_SSH</a:t>
+            </a:r>
+          </a:p>
+          <a:p>
+            <a:r>
+              <a:rPr lang="en-US" sz="1000" noProof="1"/>
+              <a:t>(list of $BASE, …, $MERGED)</a:t>
+            </a:r>
+            <a:endParaRPr lang="en-US" sz="1000" dirty="0"/>
+          </a:p>
+        </p:txBody>
+      </p:sp>
       <p:cxnSp>
         <p:nvCxnSpPr>
-          <p:cNvPr id="42" name="Straight Arrow Connector 41">
-            <a:extLst>
-              <a:ext uri="{FF2B5EF4-FFF2-40B4-BE49-F238E27FC236}">
-                <a16:creationId xmlns:a16="http://schemas.microsoft.com/office/drawing/2014/main" id="{60903B31-E932-61A5-A3D1-E1DB5CF7681A}"/>
+          <p:cNvPr id="52" name="Straight Arrow Connector 51">
+            <a:extLst>
+              <a:ext uri="{FF2B5EF4-FFF2-40B4-BE49-F238E27FC236}">
+                <a16:creationId xmlns:a16="http://schemas.microsoft.com/office/drawing/2014/main" id="{0E714552-0705-9D58-E461-2C8491339554}"/>
               </a:ext>
             </a:extLst>
           </p:cNvPr>
@@ -19379,8 +19325,8 @@
         </p:nvCxnSpPr>
         <p:spPr>
           <a:xfrm>
-            <a:off x="6865307" y="3136295"/>
-            <a:ext cx="0" cy="493894"/>
+            <a:off x="6776306" y="3863880"/>
+            <a:ext cx="0" cy="790035"/>
           </a:xfrm>
           <a:prstGeom prst="straightConnector1">
             <a:avLst/>
@@ -19406,10 +19352,10 @@
       </p:cxnSp>
       <p:sp>
         <p:nvSpPr>
-          <p:cNvPr id="46" name="TextBox 45">
-            <a:extLst>
-              <a:ext uri="{FF2B5EF4-FFF2-40B4-BE49-F238E27FC236}">
-                <a16:creationId xmlns:a16="http://schemas.microsoft.com/office/drawing/2014/main" id="{F19CDB1A-EBE4-CE30-3404-1F0553AA9FF5}"/>
+          <p:cNvPr id="55" name="TextBox 54">
+            <a:extLst>
+              <a:ext uri="{FF2B5EF4-FFF2-40B4-BE49-F238E27FC236}">
+                <a16:creationId xmlns:a16="http://schemas.microsoft.com/office/drawing/2014/main" id="{387A9F6C-A406-5B6C-7E8B-C14BBD414588}"/>
               </a:ext>
             </a:extLst>
           </p:cNvPr>
@@ -19418,8 +19364,8 @@
         </p:nvSpPr>
         <p:spPr>
           <a:xfrm>
-            <a:off x="9186409" y="3383968"/>
-            <a:ext cx="2317325" cy="246221"/>
+            <a:off x="6789504" y="3803306"/>
+            <a:ext cx="2145471" cy="400110"/>
           </a:xfrm>
           <a:prstGeom prst="rect">
             <a:avLst/>
@@ -19434,125 +19380,6 @@
           <a:p>
             <a:r>
               <a:rPr lang="en-US" sz="1000" noProof="1"/>
-              <a:t>$TMP/pragma-merge-running-ssh</a:t>
-            </a:r>
-            <a:endParaRPr lang="en-US" sz="1000" dirty="0"/>
-          </a:p>
-        </p:txBody>
-      </p:sp>
-      <p:sp>
-        <p:nvSpPr>
-          <p:cNvPr id="47" name="TextBox 46">
-            <a:extLst>
-              <a:ext uri="{FF2B5EF4-FFF2-40B4-BE49-F238E27FC236}">
-                <a16:creationId xmlns:a16="http://schemas.microsoft.com/office/drawing/2014/main" id="{8646281E-85BC-5DF3-3988-A0AA51D3C13B}"/>
-              </a:ext>
-            </a:extLst>
-          </p:cNvPr>
-          <p:cNvSpPr txBox="1"/>
-          <p:nvPr/>
-        </p:nvSpPr>
-        <p:spPr>
-          <a:xfrm>
-            <a:off x="9186409" y="3598056"/>
-            <a:ext cx="2317325" cy="400110"/>
-          </a:xfrm>
-          <a:prstGeom prst="rect">
-            <a:avLst/>
-          </a:prstGeom>
-          <a:noFill/>
-        </p:spPr>
-        <p:txBody>
-          <a:bodyPr wrap="square">
-            <a:spAutoFit/>
-          </a:bodyPr>
-          <a:lstStyle/>
-          <a:p>
-            <a:r>
-              <a:rPr lang="en-US" sz="1000" noProof="1"/>
-              <a:t>$FILE_LIST_ON_SSH</a:t>
-            </a:r>
-          </a:p>
-          <a:p>
-            <a:r>
-              <a:rPr lang="en-US" sz="1000" noProof="1"/>
-              <a:t>(list of $BASE, …, $MERGED)</a:t>
-            </a:r>
-            <a:endParaRPr lang="en-US" sz="1000" dirty="0"/>
-          </a:p>
-        </p:txBody>
-      </p:sp>
-      <p:cxnSp>
-        <p:nvCxnSpPr>
-          <p:cNvPr id="52" name="Straight Arrow Connector 51">
-            <a:extLst>
-              <a:ext uri="{FF2B5EF4-FFF2-40B4-BE49-F238E27FC236}">
-                <a16:creationId xmlns:a16="http://schemas.microsoft.com/office/drawing/2014/main" id="{0E714552-0705-9D58-E461-2C8491339554}"/>
-              </a:ext>
-            </a:extLst>
-          </p:cNvPr>
-          <p:cNvCxnSpPr>
-            <a:cxnSpLocks/>
-          </p:cNvCxnSpPr>
-          <p:nvPr/>
-        </p:nvCxnSpPr>
-        <p:spPr>
-          <a:xfrm>
-            <a:off x="6776306" y="3863880"/>
-            <a:ext cx="0" cy="790035"/>
-          </a:xfrm>
-          <a:prstGeom prst="straightConnector1">
-            <a:avLst/>
-          </a:prstGeom>
-          <a:ln>
-            <a:tailEnd type="triangle"/>
-          </a:ln>
-        </p:spPr>
-        <p:style>
-          <a:lnRef idx="1">
-            <a:schemeClr val="accent1"/>
-          </a:lnRef>
-          <a:fillRef idx="0">
-            <a:schemeClr val="accent1"/>
-          </a:fillRef>
-          <a:effectRef idx="0">
-            <a:schemeClr val="accent1"/>
-          </a:effectRef>
-          <a:fontRef idx="minor">
-            <a:schemeClr val="tx1"/>
-          </a:fontRef>
-        </p:style>
-      </p:cxnSp>
-      <p:sp>
-        <p:nvSpPr>
-          <p:cNvPr id="55" name="TextBox 54">
-            <a:extLst>
-              <a:ext uri="{FF2B5EF4-FFF2-40B4-BE49-F238E27FC236}">
-                <a16:creationId xmlns:a16="http://schemas.microsoft.com/office/drawing/2014/main" id="{387A9F6C-A406-5B6C-7E8B-C14BBD414588}"/>
-              </a:ext>
-            </a:extLst>
-          </p:cNvPr>
-          <p:cNvSpPr txBox="1"/>
-          <p:nvPr/>
-        </p:nvSpPr>
-        <p:spPr>
-          <a:xfrm>
-            <a:off x="6789504" y="3803306"/>
-            <a:ext cx="2145471" cy="400110"/>
-          </a:xfrm>
-          <a:prstGeom prst="rect">
-            <a:avLst/>
-          </a:prstGeom>
-          <a:noFill/>
-        </p:spPr>
-        <p:txBody>
-          <a:bodyPr wrap="square">
-            <a:spAutoFit/>
-          </a:bodyPr>
-          <a:lstStyle/>
-          <a:p>
-            <a:r>
-              <a:rPr lang="en-US" sz="1000" noProof="1"/>
               <a:t>Download $FILE_LIST_ON_SSH to</a:t>
             </a:r>
             <a:br>
@@ -19580,7 +19407,7 @@
         </p:nvSpPr>
         <p:spPr>
           <a:xfrm>
-            <a:off x="8800012" y="2274000"/>
+            <a:off x="8800012" y="2462540"/>
             <a:ext cx="2370855" cy="400110"/>
           </a:xfrm>
           <a:prstGeom prst="rect">
@@ -19637,8 +19464,8 @@
         </p:nvCxnSpPr>
         <p:spPr>
           <a:xfrm>
-            <a:off x="9019186" y="2508824"/>
-            <a:ext cx="0" cy="726962"/>
+            <a:off x="9019186" y="2883274"/>
+            <a:ext cx="0" cy="352512"/>
           </a:xfrm>
           <a:prstGeom prst="straightConnector1">
             <a:avLst/>
@@ -19678,12 +19505,12 @@
         </p:nvCxnSpPr>
         <p:spPr>
           <a:xfrm rot="10800000" flipV="1">
-            <a:off x="8183522" y="2838015"/>
-            <a:ext cx="2279630" cy="1234283"/>
+            <a:off x="8183522" y="3088007"/>
+            <a:ext cx="2435764" cy="984288"/>
           </a:xfrm>
           <a:prstGeom prst="bentConnector3">
             <a:avLst>
-              <a:gd name="adj1" fmla="val -29674"/>
+              <a:gd name="adj1" fmla="val -23533"/>
             </a:avLst>
           </a:prstGeom>
           <a:ln>
@@ -20051,9 +19878,9 @@
           <p:nvPr/>
         </p:nvCxnSpPr>
         <p:spPr>
-          <a:xfrm flipV="1">
-            <a:off x="8183522" y="2410353"/>
-            <a:ext cx="635279" cy="98471"/>
+          <a:xfrm>
+            <a:off x="8183522" y="2508824"/>
+            <a:ext cx="647681" cy="0"/>
           </a:xfrm>
           <a:prstGeom prst="straightConnector1">
             <a:avLst/>
@@ -20214,101 +20041,24 @@
       </p:sp>
       <p:sp>
         <p:nvSpPr>
-          <p:cNvPr id="123" name="TextBox 122">
-            <a:extLst>
-              <a:ext uri="{FF2B5EF4-FFF2-40B4-BE49-F238E27FC236}">
-                <a16:creationId xmlns:a16="http://schemas.microsoft.com/office/drawing/2014/main" id="{82A768C5-C01A-F7A0-9460-AB7B5E06D572}"/>
-              </a:ext>
-            </a:extLst>
-          </p:cNvPr>
-          <p:cNvSpPr txBox="1"/>
-          <p:nvPr/>
-        </p:nvSpPr>
-        <p:spPr>
-          <a:xfrm>
-            <a:off x="10602102" y="2229497"/>
-            <a:ext cx="370614" cy="369332"/>
-          </a:xfrm>
-          <a:prstGeom prst="rect">
-            <a:avLst/>
-          </a:prstGeom>
-          <a:noFill/>
-        </p:spPr>
-        <p:txBody>
-          <a:bodyPr wrap="none" rtlCol="0">
-            <a:spAutoFit/>
-          </a:bodyPr>
-          <a:lstStyle/>
-          <a:p>
-            <a:r>
-              <a:rPr lang="en-US" dirty="0"/>
-              <a:t>*)</a:t>
-            </a:r>
-          </a:p>
-        </p:txBody>
-      </p:sp>
-      <p:sp>
-        <p:nvSpPr>
-          <p:cNvPr id="125" name="TextBox 124">
-            <a:extLst>
-              <a:ext uri="{FF2B5EF4-FFF2-40B4-BE49-F238E27FC236}">
-                <a16:creationId xmlns:a16="http://schemas.microsoft.com/office/drawing/2014/main" id="{8B358EA0-578D-7F51-4C46-323472194A32}"/>
-              </a:ext>
-            </a:extLst>
-          </p:cNvPr>
-          <p:cNvSpPr txBox="1"/>
-          <p:nvPr/>
-        </p:nvSpPr>
-        <p:spPr>
-          <a:xfrm>
-            <a:off x="8020081" y="2736799"/>
-            <a:ext cx="370614" cy="369332"/>
-          </a:xfrm>
-          <a:prstGeom prst="rect">
-            <a:avLst/>
-          </a:prstGeom>
-          <a:noFill/>
-        </p:spPr>
-        <p:txBody>
-          <a:bodyPr wrap="none" rtlCol="0">
-            <a:spAutoFit/>
-          </a:bodyPr>
-          <a:lstStyle/>
-          <a:p>
-            <a:r>
-              <a:rPr lang="en-US" dirty="0"/>
-              <a:t>*)</a:t>
-            </a:r>
-          </a:p>
-        </p:txBody>
-      </p:sp>
-      <p:cxnSp>
-        <p:nvCxnSpPr>
-          <p:cNvPr id="148" name="Elbow Connector 147">
-            <a:extLst>
-              <a:ext uri="{FF2B5EF4-FFF2-40B4-BE49-F238E27FC236}">
-                <a16:creationId xmlns:a16="http://schemas.microsoft.com/office/drawing/2014/main" id="{B7F06132-3A6C-A784-7D8D-1B25F2E72538}"/>
-              </a:ext>
-            </a:extLst>
-          </p:cNvPr>
-          <p:cNvCxnSpPr>
-            <a:cxnSpLocks/>
-          </p:cNvCxnSpPr>
-          <p:nvPr/>
-        </p:nvCxnSpPr>
-        <p:spPr>
-          <a:xfrm rot="10800000" flipH="1" flipV="1">
-            <a:off x="6445246" y="2409337"/>
-            <a:ext cx="61298" cy="504725"/>
-          </a:xfrm>
-          <a:prstGeom prst="bentConnector3">
-            <a:avLst>
-              <a:gd name="adj1" fmla="val -372932"/>
-            </a:avLst>
-          </a:prstGeom>
-          <a:ln>
-            <a:tailEnd type="triangle"/>
-          </a:ln>
+          <p:cNvPr id="154" name="Right Brace 153">
+            <a:extLst>
+              <a:ext uri="{FF2B5EF4-FFF2-40B4-BE49-F238E27FC236}">
+                <a16:creationId xmlns:a16="http://schemas.microsoft.com/office/drawing/2014/main" id="{01315884-FD97-7EEA-38CB-A655991C0B26}"/>
+              </a:ext>
+            </a:extLst>
+          </p:cNvPr>
+          <p:cNvSpPr/>
+          <p:nvPr/>
+        </p:nvSpPr>
+        <p:spPr>
+          <a:xfrm>
+            <a:off x="10302322" y="2880051"/>
+            <a:ext cx="138162" cy="393374"/>
+          </a:xfrm>
+          <a:prstGeom prst="rightBrace">
+            <a:avLst/>
+          </a:prstGeom>
         </p:spPr>
         <p:style>
           <a:lnRef idx="1">
@@ -20324,82 +20074,6 @@
             <a:schemeClr val="tx1"/>
           </a:fontRef>
         </p:style>
-      </p:cxnSp>
-      <p:sp>
-        <p:nvSpPr>
-          <p:cNvPr id="152" name="TextBox 151">
-            <a:extLst>
-              <a:ext uri="{FF2B5EF4-FFF2-40B4-BE49-F238E27FC236}">
-                <a16:creationId xmlns:a16="http://schemas.microsoft.com/office/drawing/2014/main" id="{C731E75D-F2CE-AE85-7D31-3749E1BA2616}"/>
-              </a:ext>
-            </a:extLst>
-          </p:cNvPr>
-          <p:cNvSpPr txBox="1"/>
-          <p:nvPr/>
-        </p:nvSpPr>
-        <p:spPr>
-          <a:xfrm>
-            <a:off x="6933550" y="3216875"/>
-            <a:ext cx="696003" cy="246221"/>
-          </a:xfrm>
-          <a:prstGeom prst="rect">
-            <a:avLst/>
-          </a:prstGeom>
-          <a:noFill/>
-        </p:spPr>
-        <p:txBody>
-          <a:bodyPr wrap="square">
-            <a:spAutoFit/>
-          </a:bodyPr>
-          <a:lstStyle/>
-          <a:p>
-            <a:r>
-              <a:rPr lang="en-US" sz="1000" noProof="1">
-                <a:solidFill>
-                  <a:schemeClr val="accent1"/>
-                </a:solidFill>
-              </a:rPr>
-              <a:t>(wait 2 s)</a:t>
-            </a:r>
-            <a:endParaRPr lang="en-US" sz="1000" dirty="0"/>
-          </a:p>
-        </p:txBody>
-      </p:sp>
-      <p:sp>
-        <p:nvSpPr>
-          <p:cNvPr id="154" name="Right Brace 153">
-            <a:extLst>
-              <a:ext uri="{FF2B5EF4-FFF2-40B4-BE49-F238E27FC236}">
-                <a16:creationId xmlns:a16="http://schemas.microsoft.com/office/drawing/2014/main" id="{01315884-FD97-7EEA-38CB-A655991C0B26}"/>
-              </a:ext>
-            </a:extLst>
-          </p:cNvPr>
-          <p:cNvSpPr/>
-          <p:nvPr/>
-        </p:nvSpPr>
-        <p:spPr>
-          <a:xfrm>
-            <a:off x="10279270" y="2686587"/>
-            <a:ext cx="138162" cy="393374"/>
-          </a:xfrm>
-          <a:prstGeom prst="rightBrace">
-            <a:avLst/>
-          </a:prstGeom>
-        </p:spPr>
-        <p:style>
-          <a:lnRef idx="1">
-            <a:schemeClr val="accent1"/>
-          </a:lnRef>
-          <a:fillRef idx="0">
-            <a:schemeClr val="accent1"/>
-          </a:fillRef>
-          <a:effectRef idx="0">
-            <a:schemeClr val="accent1"/>
-          </a:effectRef>
-          <a:fontRef idx="minor">
-            <a:schemeClr val="tx1"/>
-          </a:fontRef>
-        </p:style>
         <p:txBody>
           <a:bodyPr rtlCol="0" anchor="ctr"/>
           <a:lstStyle/>
@@ -20448,48 +20122,6 @@
               <a:t>SSH-folder-documentation.xlsx</a:t>
             </a:r>
             <a:endParaRPr lang="en-US" sz="1400" b="1" dirty="0"/>
-          </a:p>
-        </p:txBody>
-      </p:sp>
-      <p:sp>
-        <p:nvSpPr>
-          <p:cNvPr id="124" name="TextBox 123">
-            <a:extLst>
-              <a:ext uri="{FF2B5EF4-FFF2-40B4-BE49-F238E27FC236}">
-                <a16:creationId xmlns:a16="http://schemas.microsoft.com/office/drawing/2014/main" id="{E0204CE5-9065-1AB6-FECE-9B20F0E87078}"/>
-              </a:ext>
-            </a:extLst>
-          </p:cNvPr>
-          <p:cNvSpPr txBox="1"/>
-          <p:nvPr/>
-        </p:nvSpPr>
-        <p:spPr>
-          <a:xfrm>
-            <a:off x="6082448" y="6369293"/>
-            <a:ext cx="5484041" cy="400110"/>
-          </a:xfrm>
-          <a:prstGeom prst="rect">
-            <a:avLst/>
-          </a:prstGeom>
-          <a:noFill/>
-        </p:spPr>
-        <p:txBody>
-          <a:bodyPr wrap="square">
-            <a:spAutoFit/>
-          </a:bodyPr>
-          <a:lstStyle/>
-          <a:p>
-            <a:r>
-              <a:rPr lang="en-US" sz="1000" noProof="1"/>
-              <a:t>*)  NOTE, git difftool waits until pragma-merge is closed. That’s why I start a delayed local</a:t>
-            </a:r>
-          </a:p>
-          <a:p>
-            <a:r>
-              <a:rPr lang="en-US" sz="1000" noProof="1"/>
-              <a:t> pick-up of files -- to give server difftool time to generate BASE, … .</a:t>
-            </a:r>
-            <a:endParaRPr lang="en-US" sz="1000" dirty="0"/>
           </a:p>
         </p:txBody>
       </p:sp>

</xml_diff>

<commit_message>
Windows ssh-folders -- fix Add Repo, terminal
- Add Repo makes key-based password-less login (stored in wsl $HOME/.ssh/ )
- Terminal can connect with ssh, including spaces in path
</commit_message>
<xml_diff>
--- a/docs/Tech-overview.pptx
+++ b/docs/Tech-overview.pptx
@@ -265,7 +265,7 @@
           <a:p>
             <a:fld id="{CA855E1B-8830-B64E-B102-DB2BBD0D9567}" type="datetimeFigureOut">
               <a:rPr lang="sv-SE" smtClean="0"/>
-              <a:t>2025-10-07</a:t>
+              <a:t>2026-03-27</a:t>
             </a:fld>
             <a:endParaRPr lang="sv-SE"/>
           </a:p>
@@ -435,7 +435,7 @@
           <a:p>
             <a:fld id="{CA855E1B-8830-B64E-B102-DB2BBD0D9567}" type="datetimeFigureOut">
               <a:rPr lang="sv-SE" smtClean="0"/>
-              <a:t>2025-10-07</a:t>
+              <a:t>2026-03-27</a:t>
             </a:fld>
             <a:endParaRPr lang="sv-SE"/>
           </a:p>
@@ -615,7 +615,7 @@
           <a:p>
             <a:fld id="{CA855E1B-8830-B64E-B102-DB2BBD0D9567}" type="datetimeFigureOut">
               <a:rPr lang="sv-SE" smtClean="0"/>
-              <a:t>2025-10-07</a:t>
+              <a:t>2026-03-27</a:t>
             </a:fld>
             <a:endParaRPr lang="sv-SE"/>
           </a:p>
@@ -785,7 +785,7 @@
           <a:p>
             <a:fld id="{CA855E1B-8830-B64E-B102-DB2BBD0D9567}" type="datetimeFigureOut">
               <a:rPr lang="sv-SE" smtClean="0"/>
-              <a:t>2025-10-07</a:t>
+              <a:t>2026-03-27</a:t>
             </a:fld>
             <a:endParaRPr lang="sv-SE"/>
           </a:p>
@@ -1029,7 +1029,7 @@
           <a:p>
             <a:fld id="{CA855E1B-8830-B64E-B102-DB2BBD0D9567}" type="datetimeFigureOut">
               <a:rPr lang="sv-SE" smtClean="0"/>
-              <a:t>2025-10-07</a:t>
+              <a:t>2026-03-27</a:t>
             </a:fld>
             <a:endParaRPr lang="sv-SE"/>
           </a:p>
@@ -1261,7 +1261,7 @@
           <a:p>
             <a:fld id="{CA855E1B-8830-B64E-B102-DB2BBD0D9567}" type="datetimeFigureOut">
               <a:rPr lang="sv-SE" smtClean="0"/>
-              <a:t>2025-10-07</a:t>
+              <a:t>2026-03-27</a:t>
             </a:fld>
             <a:endParaRPr lang="sv-SE"/>
           </a:p>
@@ -1628,7 +1628,7 @@
           <a:p>
             <a:fld id="{CA855E1B-8830-B64E-B102-DB2BBD0D9567}" type="datetimeFigureOut">
               <a:rPr lang="sv-SE" smtClean="0"/>
-              <a:t>2025-10-07</a:t>
+              <a:t>2026-03-27</a:t>
             </a:fld>
             <a:endParaRPr lang="sv-SE"/>
           </a:p>
@@ -1746,7 +1746,7 @@
           <a:p>
             <a:fld id="{CA855E1B-8830-B64E-B102-DB2BBD0D9567}" type="datetimeFigureOut">
               <a:rPr lang="sv-SE" smtClean="0"/>
-              <a:t>2025-10-07</a:t>
+              <a:t>2026-03-27</a:t>
             </a:fld>
             <a:endParaRPr lang="sv-SE"/>
           </a:p>
@@ -1841,7 +1841,7 @@
           <a:p>
             <a:fld id="{CA855E1B-8830-B64E-B102-DB2BBD0D9567}" type="datetimeFigureOut">
               <a:rPr lang="sv-SE" smtClean="0"/>
-              <a:t>2025-10-07</a:t>
+              <a:t>2026-03-27</a:t>
             </a:fld>
             <a:endParaRPr lang="sv-SE"/>
           </a:p>
@@ -2118,7 +2118,7 @@
           <a:p>
             <a:fld id="{CA855E1B-8830-B64E-B102-DB2BBD0D9567}" type="datetimeFigureOut">
               <a:rPr lang="sv-SE" smtClean="0"/>
-              <a:t>2025-10-07</a:t>
+              <a:t>2026-03-27</a:t>
             </a:fld>
             <a:endParaRPr lang="sv-SE"/>
           </a:p>
@@ -2375,7 +2375,7 @@
           <a:p>
             <a:fld id="{CA855E1B-8830-B64E-B102-DB2BBD0D9567}" type="datetimeFigureOut">
               <a:rPr lang="sv-SE" smtClean="0"/>
-              <a:t>2025-10-07</a:t>
+              <a:t>2026-03-27</a:t>
             </a:fld>
             <a:endParaRPr lang="sv-SE"/>
           </a:p>
@@ -2588,7 +2588,7 @@
           <a:p>
             <a:fld id="{CA855E1B-8830-B64E-B102-DB2BBD0D9567}" type="datetimeFigureOut">
               <a:rPr lang="sv-SE" smtClean="0"/>
-              <a:t>2025-10-07</a:t>
+              <a:t>2026-03-27</a:t>
             </a:fld>
             <a:endParaRPr lang="sv-SE"/>
           </a:p>
@@ -17169,7 +17169,7 @@
         <p:spPr>
           <a:xfrm>
             <a:off x="498476" y="1440853"/>
-            <a:ext cx="5497880" cy="3908762"/>
+            <a:ext cx="5497880" cy="3785652"/>
           </a:xfrm>
           <a:prstGeom prst="rect">
             <a:avLst/>
@@ -17318,12 +17318,6 @@
               <a:rPr lang="en-US" sz="800" noProof="1"/>
               <a:t>Other arguments are same as for local git (except –PIPED, see below)</a:t>
             </a:r>
-          </a:p>
-          <a:p>
-            <a:pPr marL="324000" lvl="1" indent="-171450">
-              <a:buFont typeface="Arial" panose="020B0604020202020204" pitchFamily="34" charset="0"/>
-              <a:buChar char="•"/>
-            </a:pPr>
             <a:endParaRPr lang="en-US" sz="800" b="1" noProof="1"/>
           </a:p>
           <a:p>
@@ -17541,7 +17535,7 @@
         </p:nvSpPr>
         <p:spPr>
           <a:xfrm>
-            <a:off x="6451812" y="5334949"/>
+            <a:off x="6451812" y="5971498"/>
             <a:ext cx="5019594" cy="2800767"/>
           </a:xfrm>
           <a:prstGeom prst="rect">
@@ -18009,7 +18003,7 @@
         <p:spPr>
           <a:xfrm>
             <a:off x="6424164" y="1456305"/>
-            <a:ext cx="5497880" cy="3170099"/>
+            <a:ext cx="5497880" cy="3785652"/>
           </a:xfrm>
           <a:prstGeom prst="rect">
             <a:avLst/>
@@ -18236,11 +18230,60 @@
             </a:r>
           </a:p>
           <a:p>
+            <a:endParaRPr lang="en-US" sz="800" b="1" noProof="1"/>
+          </a:p>
+          <a:p>
+            <a:pPr marL="171450" indent="-171450">
+              <a:buFont typeface="Courier New" panose="02070309020205020404" pitchFamily="49" charset="0"/>
+              <a:buChar char="o"/>
+            </a:pPr>
+            <a:r>
+              <a:rPr lang="en-US" sz="800" noProof="1">
+                <a:solidFill>
+                  <a:schemeClr val="accent1"/>
+                </a:solidFill>
+              </a:rPr>
+              <a:t>WSL for windows</a:t>
+            </a:r>
+            <a:endParaRPr lang="en-US" sz="800" noProof="1"/>
+          </a:p>
+          <a:p>
             <a:pPr marL="324000" lvl="1" indent="-171450">
               <a:buFont typeface="Arial" panose="020B0604020202020204" pitchFamily="34" charset="0"/>
               <a:buChar char="•"/>
             </a:pPr>
+            <a:r>
+              <a:rPr lang="en-US" sz="800" noProof="1"/>
+              <a:t>Runs in WSL on windows (which requires some path translations).  Normal bash for linux and Mac</a:t>
+            </a:r>
+          </a:p>
+          <a:p>
+            <a:endParaRPr lang="en-US" sz="800" b="1" noProof="1"/>
+          </a:p>
+          <a:p>
+            <a:pPr marL="171450" indent="-171450">
+              <a:buFont typeface="Courier New" panose="02070309020205020404" pitchFamily="49" charset="0"/>
+              <a:buChar char="o"/>
+            </a:pPr>
+            <a:r>
+              <a:rPr lang="en-US" sz="800" noProof="1">
+                <a:solidFill>
+                  <a:schemeClr val="accent1"/>
+                </a:solidFill>
+              </a:rPr>
+              <a:t>Requirements</a:t>
+            </a:r>
             <a:endParaRPr lang="en-US" sz="800" noProof="1"/>
+          </a:p>
+          <a:p>
+            <a:pPr marL="324000" lvl="1" indent="-171450">
+              <a:buFont typeface="Arial" panose="020B0604020202020204" pitchFamily="34" charset="0"/>
+              <a:buChar char="•"/>
+            </a:pPr>
+            <a:r>
+              <a:rPr lang="en-US" sz="800" noProof="1"/>
+              <a:t>password-less login (Tool for setup in Settings / Add Repo button, set switch to “server”)</a:t>
+            </a:r>
           </a:p>
         </p:txBody>
       </p:sp>
@@ -18293,7 +18336,7 @@
         </p:nvSpPr>
         <p:spPr>
           <a:xfrm>
-            <a:off x="6314718" y="4800600"/>
+            <a:off x="6314718" y="5437149"/>
             <a:ext cx="3354508" cy="461665"/>
           </a:xfrm>
           <a:prstGeom prst="rect">

</xml_diff>